<commit_message>
docs(demos): presentacion comercial — planes solo por usuarios, API key del cliente, sube plan grande
Ajustes pedidos:
- TODAS las funciones disponibles en TODOS los planes: se elimina el feature-
  gating. Los planes ahora se diferencian SOLO por cantidad de usuarios. La slide
  de comparativa "qué incluye cada plan" se reemplaza por "Todo incluido — todas
  las funciones, en todos los planes" (grid de 16 funciones, sin bloqueos).
- API key de IA a cargo del cliente: nota explícita ("El API key de IA lo pones
  tú: sin sobrecosto de uso de IA en la suscripción") + footnote de precios. El
  precio cubre plataforma + infraestructura + soporte, no el uso de IA.
- Plan grande sube: Institucional $699 -> $1.290/mes (la infra a esa escala la
  administra el proveedor y cuesta más). Esencial $99 y Profesional $299 sin cambio.

Co-Authored-By: Claude Opus 4.8 (1M context) <noreply@anthropic.com>
</commit_message>
<xml_diff>
--- a/docs/demos/presentacion/ExamLab-Presentacion-Comercial.pptx
+++ b/docs/demos/presentacion/ExamLab-Presentacion-Comercial.pptx
@@ -2364,8 +2364,8 @@
         </p:nvSpPr>
         <p:spPr>
           <a:xfrm>
-            <a:off x="548640" y="164592"/>
-            <a:ext cx="10058400" cy="274320"/>
+            <a:off x="548640" y="128016"/>
+            <a:ext cx="10058400" cy="256032"/>
           </a:xfrm>
           <a:prstGeom prst="rect">
             <a:avLst/>
@@ -2400,37 +2400,73 @@
         </p:nvSpPr>
         <p:spPr>
           <a:xfrm>
-            <a:off x="548640" y="420624"/>
-            <a:ext cx="10972800" cy="548640"/>
-          </a:xfrm>
-          <a:prstGeom prst="rect">
-            <a:avLst/>
-          </a:prstGeom>
-          <a:noFill/>
-          <a:ln/>
-        </p:spPr>
-        <p:txBody>
-          <a:bodyPr wrap="square" rtlCol="0" anchor="ctr"/>
-          <a:lstStyle/>
-          <a:p>
-            <a:pPr indent="0" marL="0">
-              <a:buNone/>
-            </a:pPr>
-            <a:r>
-              <a:rPr lang="en-US" sz="2400" b="1" dirty="0">
+            <a:off x="548640" y="365760"/>
+            <a:ext cx="10972800" cy="457200"/>
+          </a:xfrm>
+          <a:prstGeom prst="rect">
+            <a:avLst/>
+          </a:prstGeom>
+          <a:noFill/>
+          <a:ln/>
+        </p:spPr>
+        <p:txBody>
+          <a:bodyPr wrap="square" rtlCol="0" anchor="ctr"/>
+          <a:lstStyle/>
+          <a:p>
+            <a:pPr indent="0" marL="0">
+              <a:buNone/>
+            </a:pPr>
+            <a:r>
+              <a:rPr lang="en-US" sz="2300" b="1" dirty="0">
                 <a:solidFill>
                   <a:srgbClr val="FFFFFF"/>
                 </a:solidFill>
               </a:rPr>
               <a:t>Un plan para cada tamaño de institución</a:t>
             </a:r>
-            <a:endParaRPr lang="en-US" sz="2400" dirty="0"/>
-          </a:p>
-        </p:txBody>
-      </p:sp>
-      <p:sp>
-        <p:nvSpPr>
-          <p:cNvPr id="5" name="Shape 3"/>
+            <a:endParaRPr lang="en-US" sz="2300" dirty="0"/>
+          </a:p>
+        </p:txBody>
+      </p:sp>
+      <p:sp>
+        <p:nvSpPr>
+          <p:cNvPr id="5" name="Text 3"/>
+          <p:cNvSpPr/>
+          <p:nvPr/>
+        </p:nvSpPr>
+        <p:spPr>
+          <a:xfrm>
+            <a:off x="548640" y="804672"/>
+            <a:ext cx="10972800" cy="256032"/>
+          </a:xfrm>
+          <a:prstGeom prst="rect">
+            <a:avLst/>
+          </a:prstGeom>
+          <a:noFill/>
+          <a:ln/>
+        </p:spPr>
+        <p:txBody>
+          <a:bodyPr wrap="square" rtlCol="0" anchor="ctr"/>
+          <a:lstStyle/>
+          <a:p>
+            <a:pPr indent="0" marL="0">
+              <a:buNone/>
+            </a:pPr>
+            <a:r>
+              <a:rPr lang="en-US" sz="1250" dirty="0">
+                <a:solidFill>
+                  <a:srgbClr val="E0E7FF"/>
+                </a:solidFill>
+              </a:rPr>
+              <a:t>Mismas funciones en todos los planes — solo cambia la cantidad de usuarios.</a:t>
+            </a:r>
+            <a:endParaRPr lang="en-US" sz="1250" dirty="0"/>
+          </a:p>
+        </p:txBody>
+      </p:sp>
+      <p:sp>
+        <p:nvSpPr>
+          <p:cNvPr id="6" name="Shape 4"/>
           <p:cNvSpPr/>
           <p:nvPr/>
         </p:nvSpPr>
@@ -2457,7 +2493,7 @@
       </p:sp>
       <p:sp>
         <p:nvSpPr>
-          <p:cNvPr id="6" name="Shape 4"/>
+          <p:cNvPr id="7" name="Shape 5"/>
           <p:cNvSpPr/>
           <p:nvPr/>
         </p:nvSpPr>
@@ -2477,7 +2513,7 @@
       </p:sp>
       <p:sp>
         <p:nvSpPr>
-          <p:cNvPr id="7" name="Text 5"/>
+          <p:cNvPr id="8" name="Text 6"/>
           <p:cNvSpPr/>
           <p:nvPr/>
         </p:nvSpPr>
@@ -2513,7 +2549,7 @@
       </p:sp>
       <p:sp>
         <p:nvSpPr>
-          <p:cNvPr id="8" name="Text 6"/>
+          <p:cNvPr id="9" name="Text 7"/>
           <p:cNvSpPr/>
           <p:nvPr/>
         </p:nvSpPr>
@@ -2549,7 +2585,7 @@
       </p:sp>
       <p:sp>
         <p:nvSpPr>
-          <p:cNvPr id="9" name="Text 7"/>
+          <p:cNvPr id="10" name="Text 8"/>
           <p:cNvSpPr/>
           <p:nvPr/>
         </p:nvSpPr>
@@ -2596,7 +2632,7 @@
       </p:sp>
       <p:sp>
         <p:nvSpPr>
-          <p:cNvPr id="10" name="Text 8"/>
+          <p:cNvPr id="11" name="Text 9"/>
           <p:cNvSpPr/>
           <p:nvPr/>
         </p:nvSpPr>
@@ -2632,7 +2668,7 @@
       </p:sp>
       <p:sp>
         <p:nvSpPr>
-          <p:cNvPr id="11" name="Text 9"/>
+          <p:cNvPr id="12" name="Text 10"/>
           <p:cNvSpPr/>
           <p:nvPr/>
         </p:nvSpPr>
@@ -2668,7 +2704,7 @@
       </p:sp>
       <p:sp>
         <p:nvSpPr>
-          <p:cNvPr id="12" name="Text 10"/>
+          <p:cNvPr id="13" name="Text 11"/>
           <p:cNvSpPr/>
           <p:nvPr/>
         </p:nvSpPr>
@@ -2704,7 +2740,7 @@
       </p:sp>
       <p:sp>
         <p:nvSpPr>
-          <p:cNvPr id="13" name="Text 11"/>
+          <p:cNvPr id="14" name="Text 12"/>
           <p:cNvSpPr/>
           <p:nvPr/>
         </p:nvSpPr>
@@ -2740,7 +2776,7 @@
       </p:sp>
       <p:sp>
         <p:nvSpPr>
-          <p:cNvPr id="14" name="Text 12"/>
+          <p:cNvPr id="15" name="Text 13"/>
           <p:cNvSpPr/>
           <p:nvPr/>
         </p:nvSpPr>
@@ -2776,7 +2812,7 @@
       </p:sp>
       <p:sp>
         <p:nvSpPr>
-          <p:cNvPr id="15" name="Text 13"/>
+          <p:cNvPr id="16" name="Text 14"/>
           <p:cNvSpPr/>
           <p:nvPr/>
         </p:nvSpPr>
@@ -2812,7 +2848,7 @@
       </p:sp>
       <p:sp>
         <p:nvSpPr>
-          <p:cNvPr id="16" name="Shape 14"/>
+          <p:cNvPr id="17" name="Shape 15"/>
           <p:cNvSpPr/>
           <p:nvPr/>
         </p:nvSpPr>
@@ -2835,7 +2871,7 @@
       </p:sp>
       <p:sp>
         <p:nvSpPr>
-          <p:cNvPr id="17" name="Text 15"/>
+          <p:cNvPr id="18" name="Text 16"/>
           <p:cNvSpPr/>
           <p:nvPr/>
         </p:nvSpPr>
@@ -2867,7 +2903,7 @@
                   <a:srgbClr val="334155"/>
                 </a:solidFill>
               </a:rPr>
-              <a:t>IA: generar y calificar</a:t>
+              <a:t>Todas las funciones incluidas</a:t>
             </a:r>
             <a:endParaRPr lang="en-US" sz="1150" dirty="0"/>
           </a:p>
@@ -2885,7 +2921,7 @@
                   <a:srgbClr val="334155"/>
                 </a:solidFill>
               </a:rPr>
-              <a:t>Asistencia con QR</a:t>
+              <a:t>Sin límite de cursos</a:t>
             </a:r>
             <a:endParaRPr lang="en-US" sz="1150" dirty="0"/>
           </a:p>
@@ -2903,7 +2939,7 @@
                   <a:srgbClr val="334155"/>
                 </a:solidFill>
               </a:rPr>
-              <a:t>Mensajería y foros</a:t>
+              <a:t>Soporte incluido</a:t>
             </a:r>
             <a:endParaRPr lang="en-US" sz="1150" dirty="0"/>
           </a:p>
@@ -2911,7 +2947,7 @@
       </p:sp>
       <p:sp>
         <p:nvSpPr>
-          <p:cNvPr id="18" name="Shape 16"/>
+          <p:cNvPr id="19" name="Shape 17"/>
           <p:cNvSpPr/>
           <p:nvPr/>
         </p:nvSpPr>
@@ -2945,7 +2981,7 @@
       </p:sp>
       <p:sp>
         <p:nvSpPr>
-          <p:cNvPr id="19" name="Text 17"/>
+          <p:cNvPr id="20" name="Text 18"/>
           <p:cNvSpPr/>
           <p:nvPr/>
         </p:nvSpPr>
@@ -2985,7 +3021,7 @@
       </p:sp>
       <p:sp>
         <p:nvSpPr>
-          <p:cNvPr id="20" name="Shape 18"/>
+          <p:cNvPr id="21" name="Shape 19"/>
           <p:cNvSpPr/>
           <p:nvPr/>
         </p:nvSpPr>
@@ -3005,7 +3041,7 @@
       </p:sp>
       <p:sp>
         <p:nvSpPr>
-          <p:cNvPr id="21" name="Text 19"/>
+          <p:cNvPr id="22" name="Text 20"/>
           <p:cNvSpPr/>
           <p:nvPr/>
         </p:nvSpPr>
@@ -3041,7 +3077,7 @@
       </p:sp>
       <p:sp>
         <p:nvSpPr>
-          <p:cNvPr id="22" name="Text 20"/>
+          <p:cNvPr id="23" name="Text 21"/>
           <p:cNvSpPr/>
           <p:nvPr/>
         </p:nvSpPr>
@@ -3077,7 +3113,7 @@
       </p:sp>
       <p:sp>
         <p:nvSpPr>
-          <p:cNvPr id="23" name="Text 21"/>
+          <p:cNvPr id="24" name="Text 22"/>
           <p:cNvSpPr/>
           <p:nvPr/>
         </p:nvSpPr>
@@ -3124,7 +3160,7 @@
       </p:sp>
       <p:sp>
         <p:nvSpPr>
-          <p:cNvPr id="24" name="Text 22"/>
+          <p:cNvPr id="25" name="Text 23"/>
           <p:cNvSpPr/>
           <p:nvPr/>
         </p:nvSpPr>
@@ -3160,7 +3196,7 @@
       </p:sp>
       <p:sp>
         <p:nvSpPr>
-          <p:cNvPr id="25" name="Text 23"/>
+          <p:cNvPr id="26" name="Text 24"/>
           <p:cNvSpPr/>
           <p:nvPr/>
         </p:nvSpPr>
@@ -3196,7 +3232,7 @@
       </p:sp>
       <p:sp>
         <p:nvSpPr>
-          <p:cNvPr id="26" name="Text 24"/>
+          <p:cNvPr id="27" name="Text 25"/>
           <p:cNvSpPr/>
           <p:nvPr/>
         </p:nvSpPr>
@@ -3232,7 +3268,7 @@
       </p:sp>
       <p:sp>
         <p:nvSpPr>
-          <p:cNvPr id="27" name="Text 25"/>
+          <p:cNvPr id="28" name="Text 26"/>
           <p:cNvSpPr/>
           <p:nvPr/>
         </p:nvSpPr>
@@ -3268,7 +3304,7 @@
       </p:sp>
       <p:sp>
         <p:nvSpPr>
-          <p:cNvPr id="28" name="Text 26"/>
+          <p:cNvPr id="29" name="Text 27"/>
           <p:cNvSpPr/>
           <p:nvPr/>
         </p:nvSpPr>
@@ -3304,7 +3340,7 @@
       </p:sp>
       <p:sp>
         <p:nvSpPr>
-          <p:cNvPr id="29" name="Text 27"/>
+          <p:cNvPr id="30" name="Text 28"/>
           <p:cNvSpPr/>
           <p:nvPr/>
         </p:nvSpPr>
@@ -3340,7 +3376,7 @@
       </p:sp>
       <p:sp>
         <p:nvSpPr>
-          <p:cNvPr id="30" name="Shape 28"/>
+          <p:cNvPr id="31" name="Shape 29"/>
           <p:cNvSpPr/>
           <p:nvPr/>
         </p:nvSpPr>
@@ -3363,7 +3399,7 @@
       </p:sp>
       <p:sp>
         <p:nvSpPr>
-          <p:cNvPr id="31" name="Text 29"/>
+          <p:cNvPr id="32" name="Text 30"/>
           <p:cNvSpPr/>
           <p:nvPr/>
         </p:nvSpPr>
@@ -3395,7 +3431,7 @@
                   <a:srgbClr val="334155"/>
                 </a:solidFill>
               </a:rPr>
-              <a:t>Todo lo de Esencial</a:t>
+              <a:t>Todas las funciones incluidas</a:t>
             </a:r>
             <a:endParaRPr lang="en-US" sz="1150" dirty="0"/>
           </a:p>
@@ -3413,7 +3449,7 @@
                   <a:srgbClr val="334155"/>
                 </a:solidFill>
               </a:rPr>
-              <a:t>Tutor IA + antifraude</a:t>
+              <a:t>Sin límite de cursos</a:t>
             </a:r>
             <a:endParaRPr lang="en-US" sz="1150" dirty="0"/>
           </a:p>
@@ -3431,7 +3467,7 @@
                   <a:srgbClr val="334155"/>
                 </a:solidFill>
               </a:rPr>
-              <a:t>Calendario + reportes</a:t>
+              <a:t>Soporte incluido</a:t>
             </a:r>
             <a:endParaRPr lang="en-US" sz="1150" dirty="0"/>
           </a:p>
@@ -3439,7 +3475,7 @@
       </p:sp>
       <p:sp>
         <p:nvSpPr>
-          <p:cNvPr id="32" name="Shape 30"/>
+          <p:cNvPr id="33" name="Shape 31"/>
           <p:cNvSpPr/>
           <p:nvPr/>
         </p:nvSpPr>
@@ -3466,7 +3502,7 @@
       </p:sp>
       <p:sp>
         <p:nvSpPr>
-          <p:cNvPr id="33" name="Shape 31"/>
+          <p:cNvPr id="34" name="Shape 32"/>
           <p:cNvSpPr/>
           <p:nvPr/>
         </p:nvSpPr>
@@ -3486,7 +3522,7 @@
       </p:sp>
       <p:sp>
         <p:nvSpPr>
-          <p:cNvPr id="34" name="Text 32"/>
+          <p:cNvPr id="35" name="Text 33"/>
           <p:cNvSpPr/>
           <p:nvPr/>
         </p:nvSpPr>
@@ -3522,7 +3558,7 @@
       </p:sp>
       <p:sp>
         <p:nvSpPr>
-          <p:cNvPr id="35" name="Text 33"/>
+          <p:cNvPr id="36" name="Text 34"/>
           <p:cNvSpPr/>
           <p:nvPr/>
         </p:nvSpPr>
@@ -3558,7 +3594,7 @@
       </p:sp>
       <p:sp>
         <p:nvSpPr>
-          <p:cNvPr id="36" name="Text 34"/>
+          <p:cNvPr id="37" name="Text 35"/>
           <p:cNvSpPr/>
           <p:nvPr/>
         </p:nvSpPr>
@@ -3586,7 +3622,7 @@
                   <a:srgbClr val="4F46E5"/>
                 </a:solidFill>
               </a:rPr>
-              <a:t>$699</a:t>
+              <a:t>$1.290</a:t>
             </a:r>
             <a:pPr indent="0" marL="0">
               <a:buNone/>
@@ -3605,7 +3641,7 @@
       </p:sp>
       <p:sp>
         <p:nvSpPr>
-          <p:cNvPr id="37" name="Text 35"/>
+          <p:cNvPr id="38" name="Text 36"/>
           <p:cNvSpPr/>
           <p:nvPr/>
         </p:nvSpPr>
@@ -3641,7 +3677,7 @@
       </p:sp>
       <p:sp>
         <p:nvSpPr>
-          <p:cNvPr id="38" name="Text 36"/>
+          <p:cNvPr id="39" name="Text 37"/>
           <p:cNvSpPr/>
           <p:nvPr/>
         </p:nvSpPr>
@@ -3677,7 +3713,7 @@
       </p:sp>
       <p:sp>
         <p:nvSpPr>
-          <p:cNvPr id="39" name="Text 37"/>
+          <p:cNvPr id="40" name="Text 38"/>
           <p:cNvSpPr/>
           <p:nvPr/>
         </p:nvSpPr>
@@ -3713,7 +3749,7 @@
       </p:sp>
       <p:sp>
         <p:nvSpPr>
-          <p:cNvPr id="40" name="Text 38"/>
+          <p:cNvPr id="41" name="Text 39"/>
           <p:cNvSpPr/>
           <p:nvPr/>
         </p:nvSpPr>
@@ -3749,7 +3785,7 @@
       </p:sp>
       <p:sp>
         <p:nvSpPr>
-          <p:cNvPr id="41" name="Text 39"/>
+          <p:cNvPr id="42" name="Text 40"/>
           <p:cNvSpPr/>
           <p:nvPr/>
         </p:nvSpPr>
@@ -3785,7 +3821,7 @@
       </p:sp>
       <p:sp>
         <p:nvSpPr>
-          <p:cNvPr id="42" name="Text 40"/>
+          <p:cNvPr id="43" name="Text 41"/>
           <p:cNvSpPr/>
           <p:nvPr/>
         </p:nvSpPr>
@@ -3821,7 +3857,7 @@
       </p:sp>
       <p:sp>
         <p:nvSpPr>
-          <p:cNvPr id="43" name="Shape 41"/>
+          <p:cNvPr id="44" name="Shape 42"/>
           <p:cNvSpPr/>
           <p:nvPr/>
         </p:nvSpPr>
@@ -3844,7 +3880,7 @@
       </p:sp>
       <p:sp>
         <p:nvSpPr>
-          <p:cNvPr id="44" name="Text 42"/>
+          <p:cNvPr id="45" name="Text 43"/>
           <p:cNvSpPr/>
           <p:nvPr/>
         </p:nvSpPr>
@@ -3876,7 +3912,7 @@
                   <a:srgbClr val="334155"/>
                 </a:solidFill>
               </a:rPr>
-              <a:t>Todo lo de Profesional</a:t>
+              <a:t>Todas las funciones incluidas</a:t>
             </a:r>
             <a:endParaRPr lang="en-US" sz="1150" dirty="0"/>
           </a:p>
@@ -3894,7 +3930,7 @@
                   <a:srgbClr val="334155"/>
                 </a:solidFill>
               </a:rPr>
-              <a:t>Multi-sede + branding</a:t>
+              <a:t>Sin límite de cursos</a:t>
             </a:r>
             <a:endParaRPr lang="en-US" sz="1150" dirty="0"/>
           </a:p>
@@ -3912,7 +3948,7 @@
                   <a:srgbClr val="334155"/>
                 </a:solidFill>
               </a:rPr>
-              <a:t>Soporte prioritario</a:t>
+              <a:t>Soporte incluido</a:t>
             </a:r>
             <a:endParaRPr lang="en-US" sz="1150" dirty="0"/>
           </a:p>
@@ -3920,14 +3956,14 @@
       </p:sp>
       <p:sp>
         <p:nvSpPr>
-          <p:cNvPr id="45" name="Text 43"/>
-          <p:cNvSpPr/>
-          <p:nvPr/>
-        </p:nvSpPr>
-        <p:spPr>
-          <a:xfrm>
-            <a:off x="502920" y="6291072"/>
-            <a:ext cx="11155680" cy="274320"/>
+          <p:cNvPr id="46" name="Text 44"/>
+          <p:cNvSpPr/>
+          <p:nvPr/>
+        </p:nvSpPr>
+        <p:spPr>
+          <a:xfrm>
+            <a:off x="502920" y="6254496"/>
+            <a:ext cx="11155680" cy="310896"/>
           </a:xfrm>
           <a:prstGeom prst="rect">
             <a:avLst/>
@@ -3948,7 +3984,7 @@
                   <a:srgbClr val="64748B"/>
                 </a:solidFill>
               </a:rPr>
-              <a:t>Valores de referencia (USD) — ajustar a la política comercial. Capacidad por institución.</a:t>
+              <a:t>Precios de referencia (USD/mes) — incluyen plataforma, infraestructura y soporte. El API key de IA lo provee la institución (su uso de IA no se factura en la suscripción). Ajustar a la política comercial.</a:t>
             </a:r>
             <a:endParaRPr lang="en-US" sz="950" dirty="0"/>
           </a:p>
@@ -3956,7 +3992,7 @@
       </p:sp>
       <p:sp>
         <p:nvSpPr>
-          <p:cNvPr id="46" name="Shape 44"/>
+          <p:cNvPr id="47" name="Shape 45"/>
           <p:cNvSpPr/>
           <p:nvPr/>
         </p:nvSpPr>
@@ -3976,7 +4012,7 @@
       </p:sp>
       <p:sp>
         <p:nvSpPr>
-          <p:cNvPr id="47" name="Text 45"/>
+          <p:cNvPr id="48" name="Text 46"/>
           <p:cNvSpPr/>
           <p:nvPr/>
         </p:nvSpPr>
@@ -4012,7 +4048,7 @@
       </p:sp>
       <p:sp>
         <p:nvSpPr>
-          <p:cNvPr id="48" name="Text 46"/>
+          <p:cNvPr id="49" name="Text 47"/>
           <p:cNvSpPr/>
           <p:nvPr/>
         </p:nvSpPr>
@@ -4087,7 +4123,7 @@
         <p:spPr>
           <a:xfrm>
             <a:off x="0" y="0"/>
-            <a:ext cx="12191695" cy="1051560"/>
+            <a:ext cx="12191695" cy="1234440"/>
           </a:xfrm>
           <a:prstGeom prst="rect">
             <a:avLst/>
@@ -4100,13 +4136,33 @@
       </p:sp>
       <p:sp>
         <p:nvSpPr>
-          <p:cNvPr id="3" name="Text 1"/>
-          <p:cNvSpPr/>
-          <p:nvPr/>
-        </p:nvSpPr>
-        <p:spPr>
-          <a:xfrm>
-            <a:off x="548640" y="164592"/>
+          <p:cNvPr id="3" name="Shape 1"/>
+          <p:cNvSpPr/>
+          <p:nvPr/>
+        </p:nvSpPr>
+        <p:spPr>
+          <a:xfrm>
+            <a:off x="0" y="1234440"/>
+            <a:ext cx="12191695" cy="54864"/>
+          </a:xfrm>
+          <a:prstGeom prst="rect">
+            <a:avLst/>
+          </a:prstGeom>
+          <a:solidFill>
+            <a:srgbClr val="059669"/>
+          </a:solidFill>
+          <a:ln/>
+        </p:spPr>
+      </p:sp>
+      <p:sp>
+        <p:nvSpPr>
+          <p:cNvPr id="4" name="Text 2"/>
+          <p:cNvSpPr/>
+          <p:nvPr/>
+        </p:nvSpPr>
+        <p:spPr>
+          <a:xfrm>
+            <a:off x="548640" y="182880"/>
             <a:ext cx="10058400" cy="274320"/>
           </a:xfrm>
           <a:prstGeom prst="rect">
@@ -4128,7 +4184,7 @@
                   <a:srgbClr val="E9D5FF"/>
                 </a:solidFill>
               </a:rPr>
-              <a:t>COMPARATIVA</a:t>
+              <a:t>TODO INCLUIDO</a:t>
             </a:r>
             <a:endParaRPr lang="en-US" sz="1100" dirty="0"/>
           </a:p>
@@ -4136,14 +4192,14 @@
       </p:sp>
       <p:sp>
         <p:nvSpPr>
-          <p:cNvPr id="4" name="Text 2"/>
+          <p:cNvPr id="5" name="Text 3"/>
           <p:cNvSpPr/>
           <p:nvPr/>
         </p:nvSpPr>
         <p:spPr>
           <a:xfrm>
             <a:off x="548640" y="420624"/>
-            <a:ext cx="10972800" cy="548640"/>
+            <a:ext cx="10972800" cy="502920"/>
           </a:xfrm>
           <a:prstGeom prst="rect">
             <a:avLst/>
@@ -4164,7 +4220,7 @@
                   <a:srgbClr val="FFFFFF"/>
                 </a:solidFill>
               </a:rPr>
-              <a:t>Qué incluye cada plan</a:t>
+              <a:t>Todas las funciones, en todos los planes</a:t>
             </a:r>
             <a:endParaRPr lang="en-US" sz="2400" dirty="0"/>
           </a:p>
@@ -4172,322 +4228,1276 @@
       </p:sp>
       <p:sp>
         <p:nvSpPr>
-          <p:cNvPr id="5" name="Shape 3"/>
-          <p:cNvSpPr/>
-          <p:nvPr/>
-        </p:nvSpPr>
-        <p:spPr>
-          <a:xfrm>
-            <a:off x="457200" y="1325880"/>
-            <a:ext cx="11338560" cy="457200"/>
-          </a:xfrm>
-          <a:prstGeom prst="rect">
-            <a:avLst/>
+          <p:cNvPr id="6" name="Text 4"/>
+          <p:cNvSpPr/>
+          <p:nvPr/>
+        </p:nvSpPr>
+        <p:spPr>
+          <a:xfrm>
+            <a:off x="548640" y="914400"/>
+            <a:ext cx="10972800" cy="274320"/>
+          </a:xfrm>
+          <a:prstGeom prst="rect">
+            <a:avLst/>
+          </a:prstGeom>
+          <a:noFill/>
+          <a:ln/>
+        </p:spPr>
+        <p:txBody>
+          <a:bodyPr wrap="square" rtlCol="0" anchor="ctr"/>
+          <a:lstStyle/>
+          <a:p>
+            <a:pPr indent="0" marL="0">
+              <a:buNone/>
+            </a:pPr>
+            <a:r>
+              <a:rPr lang="en-US" sz="1250" dirty="0">
+                <a:solidFill>
+                  <a:srgbClr val="E9D5FF"/>
+                </a:solidFill>
+              </a:rPr>
+              <a:t>Sin funciones bloqueadas: la única diferencia entre planes es la cantidad de usuarios.</a:t>
+            </a:r>
+            <a:endParaRPr lang="en-US" sz="1250" dirty="0"/>
+          </a:p>
+        </p:txBody>
+      </p:sp>
+      <p:sp>
+        <p:nvSpPr>
+          <p:cNvPr id="7" name="Text 5"/>
+          <p:cNvSpPr/>
+          <p:nvPr/>
+        </p:nvSpPr>
+        <p:spPr>
+          <a:xfrm>
+            <a:off x="640080" y="1600200"/>
+            <a:ext cx="365760" cy="475488"/>
+          </a:xfrm>
+          <a:prstGeom prst="rect">
+            <a:avLst/>
+          </a:prstGeom>
+          <a:noFill/>
+          <a:ln/>
+        </p:spPr>
+        <p:txBody>
+          <a:bodyPr wrap="square" rtlCol="0" anchor="ctr"/>
+          <a:lstStyle/>
+          <a:p>
+            <a:pPr indent="0" marL="0">
+              <a:buNone/>
+            </a:pPr>
+            <a:r>
+              <a:rPr lang="en-US" sz="1400" b="1" dirty="0">
+                <a:solidFill>
+                  <a:srgbClr val="059669"/>
+                </a:solidFill>
+              </a:rPr>
+              <a:t>✓</a:t>
+            </a:r>
+            <a:endParaRPr lang="en-US" sz="1400" dirty="0"/>
+          </a:p>
+        </p:txBody>
+      </p:sp>
+      <p:sp>
+        <p:nvSpPr>
+          <p:cNvPr id="8" name="Text 6"/>
+          <p:cNvSpPr/>
+          <p:nvPr/>
+        </p:nvSpPr>
+        <p:spPr>
+          <a:xfrm>
+            <a:off x="1024128" y="1600200"/>
+            <a:ext cx="5102352" cy="475488"/>
+          </a:xfrm>
+          <a:prstGeom prst="rect">
+            <a:avLst/>
+          </a:prstGeom>
+          <a:noFill/>
+          <a:ln/>
+        </p:spPr>
+        <p:txBody>
+          <a:bodyPr wrap="square" rtlCol="0" anchor="ctr"/>
+          <a:lstStyle/>
+          <a:p>
+            <a:pPr indent="0" marL="0">
+              <a:buNone/>
+            </a:pPr>
+            <a:r>
+              <a:rPr lang="en-US" sz="1300" dirty="0">
+                <a:solidFill>
+                  <a:srgbClr val="1E1B4B"/>
+                </a:solidFill>
+              </a:rPr>
+              <a:t>Cursos, cronograma y tablero</a:t>
+            </a:r>
+            <a:endParaRPr lang="en-US" sz="1300" dirty="0"/>
+          </a:p>
+        </p:txBody>
+      </p:sp>
+      <p:sp>
+        <p:nvSpPr>
+          <p:cNvPr id="9" name="Text 7"/>
+          <p:cNvSpPr/>
+          <p:nvPr/>
+        </p:nvSpPr>
+        <p:spPr>
+          <a:xfrm>
+            <a:off x="640080" y="2075688"/>
+            <a:ext cx="365760" cy="475488"/>
+          </a:xfrm>
+          <a:prstGeom prst="rect">
+            <a:avLst/>
+          </a:prstGeom>
+          <a:noFill/>
+          <a:ln/>
+        </p:spPr>
+        <p:txBody>
+          <a:bodyPr wrap="square" rtlCol="0" anchor="ctr"/>
+          <a:lstStyle/>
+          <a:p>
+            <a:pPr indent="0" marL="0">
+              <a:buNone/>
+            </a:pPr>
+            <a:r>
+              <a:rPr lang="en-US" sz="1400" b="1" dirty="0">
+                <a:solidFill>
+                  <a:srgbClr val="059669"/>
+                </a:solidFill>
+              </a:rPr>
+              <a:t>✓</a:t>
+            </a:r>
+            <a:endParaRPr lang="en-US" sz="1400" dirty="0"/>
+          </a:p>
+        </p:txBody>
+      </p:sp>
+      <p:sp>
+        <p:nvSpPr>
+          <p:cNvPr id="10" name="Text 8"/>
+          <p:cNvSpPr/>
+          <p:nvPr/>
+        </p:nvSpPr>
+        <p:spPr>
+          <a:xfrm>
+            <a:off x="1024128" y="2075688"/>
+            <a:ext cx="5102352" cy="475488"/>
+          </a:xfrm>
+          <a:prstGeom prst="rect">
+            <a:avLst/>
+          </a:prstGeom>
+          <a:noFill/>
+          <a:ln/>
+        </p:spPr>
+        <p:txBody>
+          <a:bodyPr wrap="square" rtlCol="0" anchor="ctr"/>
+          <a:lstStyle/>
+          <a:p>
+            <a:pPr indent="0" marL="0">
+              <a:buNone/>
+            </a:pPr>
+            <a:r>
+              <a:rPr lang="en-US" sz="1300" dirty="0">
+                <a:solidFill>
+                  <a:srgbClr val="1E1B4B"/>
+                </a:solidFill>
+              </a:rPr>
+              <a:t>Exámenes, talleres y proyectos</a:t>
+            </a:r>
+            <a:endParaRPr lang="en-US" sz="1300" dirty="0"/>
+          </a:p>
+        </p:txBody>
+      </p:sp>
+      <p:sp>
+        <p:nvSpPr>
+          <p:cNvPr id="11" name="Text 9"/>
+          <p:cNvSpPr/>
+          <p:nvPr/>
+        </p:nvSpPr>
+        <p:spPr>
+          <a:xfrm>
+            <a:off x="640080" y="2551176"/>
+            <a:ext cx="365760" cy="475488"/>
+          </a:xfrm>
+          <a:prstGeom prst="rect">
+            <a:avLst/>
+          </a:prstGeom>
+          <a:noFill/>
+          <a:ln/>
+        </p:spPr>
+        <p:txBody>
+          <a:bodyPr wrap="square" rtlCol="0" anchor="ctr"/>
+          <a:lstStyle/>
+          <a:p>
+            <a:pPr indent="0" marL="0">
+              <a:buNone/>
+            </a:pPr>
+            <a:r>
+              <a:rPr lang="en-US" sz="1400" b="1" dirty="0">
+                <a:solidFill>
+                  <a:srgbClr val="059669"/>
+                </a:solidFill>
+              </a:rPr>
+              <a:t>✓</a:t>
+            </a:r>
+            <a:endParaRPr lang="en-US" sz="1400" dirty="0"/>
+          </a:p>
+        </p:txBody>
+      </p:sp>
+      <p:sp>
+        <p:nvSpPr>
+          <p:cNvPr id="12" name="Text 10"/>
+          <p:cNvSpPr/>
+          <p:nvPr/>
+        </p:nvSpPr>
+        <p:spPr>
+          <a:xfrm>
+            <a:off x="1024128" y="2551176"/>
+            <a:ext cx="5102352" cy="475488"/>
+          </a:xfrm>
+          <a:prstGeom prst="rect">
+            <a:avLst/>
+          </a:prstGeom>
+          <a:noFill/>
+          <a:ln/>
+        </p:spPr>
+        <p:txBody>
+          <a:bodyPr wrap="square" rtlCol="0" anchor="ctr"/>
+          <a:lstStyle/>
+          <a:p>
+            <a:pPr indent="0" marL="0">
+              <a:buNone/>
+            </a:pPr>
+            <a:r>
+              <a:rPr lang="en-US" sz="1300" dirty="0">
+                <a:solidFill>
+                  <a:srgbClr val="1E1B4B"/>
+                </a:solidFill>
+              </a:rPr>
+              <a:t>Generación de evaluaciones con IA</a:t>
+            </a:r>
+            <a:endParaRPr lang="en-US" sz="1300" dirty="0"/>
+          </a:p>
+        </p:txBody>
+      </p:sp>
+      <p:sp>
+        <p:nvSpPr>
+          <p:cNvPr id="13" name="Text 11"/>
+          <p:cNvSpPr/>
+          <p:nvPr/>
+        </p:nvSpPr>
+        <p:spPr>
+          <a:xfrm>
+            <a:off x="640080" y="3026664"/>
+            <a:ext cx="365760" cy="475488"/>
+          </a:xfrm>
+          <a:prstGeom prst="rect">
+            <a:avLst/>
+          </a:prstGeom>
+          <a:noFill/>
+          <a:ln/>
+        </p:spPr>
+        <p:txBody>
+          <a:bodyPr wrap="square" rtlCol="0" anchor="ctr"/>
+          <a:lstStyle/>
+          <a:p>
+            <a:pPr indent="0" marL="0">
+              <a:buNone/>
+            </a:pPr>
+            <a:r>
+              <a:rPr lang="en-US" sz="1400" b="1" dirty="0">
+                <a:solidFill>
+                  <a:srgbClr val="059669"/>
+                </a:solidFill>
+              </a:rPr>
+              <a:t>✓</a:t>
+            </a:r>
+            <a:endParaRPr lang="en-US" sz="1400" dirty="0"/>
+          </a:p>
+        </p:txBody>
+      </p:sp>
+      <p:sp>
+        <p:nvSpPr>
+          <p:cNvPr id="14" name="Text 12"/>
+          <p:cNvSpPr/>
+          <p:nvPr/>
+        </p:nvSpPr>
+        <p:spPr>
+          <a:xfrm>
+            <a:off x="1024128" y="3026664"/>
+            <a:ext cx="5102352" cy="475488"/>
+          </a:xfrm>
+          <a:prstGeom prst="rect">
+            <a:avLst/>
+          </a:prstGeom>
+          <a:noFill/>
+          <a:ln/>
+        </p:spPr>
+        <p:txBody>
+          <a:bodyPr wrap="square" rtlCol="0" anchor="ctr"/>
+          <a:lstStyle/>
+          <a:p>
+            <a:pPr indent="0" marL="0">
+              <a:buNone/>
+            </a:pPr>
+            <a:r>
+              <a:rPr lang="en-US" sz="1300" dirty="0">
+                <a:solidFill>
+                  <a:srgbClr val="1E1B4B"/>
+                </a:solidFill>
+              </a:rPr>
+              <a:t>Generación de contenido (PPTX/guías) con IA</a:t>
+            </a:r>
+            <a:endParaRPr lang="en-US" sz="1300" dirty="0"/>
+          </a:p>
+        </p:txBody>
+      </p:sp>
+      <p:sp>
+        <p:nvSpPr>
+          <p:cNvPr id="15" name="Text 13"/>
+          <p:cNvSpPr/>
+          <p:nvPr/>
+        </p:nvSpPr>
+        <p:spPr>
+          <a:xfrm>
+            <a:off x="640080" y="3502152"/>
+            <a:ext cx="365760" cy="475488"/>
+          </a:xfrm>
+          <a:prstGeom prst="rect">
+            <a:avLst/>
+          </a:prstGeom>
+          <a:noFill/>
+          <a:ln/>
+        </p:spPr>
+        <p:txBody>
+          <a:bodyPr wrap="square" rtlCol="0" anchor="ctr"/>
+          <a:lstStyle/>
+          <a:p>
+            <a:pPr indent="0" marL="0">
+              <a:buNone/>
+            </a:pPr>
+            <a:r>
+              <a:rPr lang="en-US" sz="1400" b="1" dirty="0">
+                <a:solidFill>
+                  <a:srgbClr val="059669"/>
+                </a:solidFill>
+              </a:rPr>
+              <a:t>✓</a:t>
+            </a:r>
+            <a:endParaRPr lang="en-US" sz="1400" dirty="0"/>
+          </a:p>
+        </p:txBody>
+      </p:sp>
+      <p:sp>
+        <p:nvSpPr>
+          <p:cNvPr id="16" name="Text 14"/>
+          <p:cNvSpPr/>
+          <p:nvPr/>
+        </p:nvSpPr>
+        <p:spPr>
+          <a:xfrm>
+            <a:off x="1024128" y="3502152"/>
+            <a:ext cx="5102352" cy="475488"/>
+          </a:xfrm>
+          <a:prstGeom prst="rect">
+            <a:avLst/>
+          </a:prstGeom>
+          <a:noFill/>
+          <a:ln/>
+        </p:spPr>
+        <p:txBody>
+          <a:bodyPr wrap="square" rtlCol="0" anchor="ctr"/>
+          <a:lstStyle/>
+          <a:p>
+            <a:pPr indent="0" marL="0">
+              <a:buNone/>
+            </a:pPr>
+            <a:r>
+              <a:rPr lang="en-US" sz="1300" dirty="0">
+                <a:solidFill>
+                  <a:srgbClr val="1E1B4B"/>
+                </a:solidFill>
+              </a:rPr>
+              <a:t>Calificación automática con retroalimentación</a:t>
+            </a:r>
+            <a:endParaRPr lang="en-US" sz="1300" dirty="0"/>
+          </a:p>
+        </p:txBody>
+      </p:sp>
+      <p:sp>
+        <p:nvSpPr>
+          <p:cNvPr id="17" name="Text 15"/>
+          <p:cNvSpPr/>
+          <p:nvPr/>
+        </p:nvSpPr>
+        <p:spPr>
+          <a:xfrm>
+            <a:off x="640080" y="3977640"/>
+            <a:ext cx="365760" cy="475488"/>
+          </a:xfrm>
+          <a:prstGeom prst="rect">
+            <a:avLst/>
+          </a:prstGeom>
+          <a:noFill/>
+          <a:ln/>
+        </p:spPr>
+        <p:txBody>
+          <a:bodyPr wrap="square" rtlCol="0" anchor="ctr"/>
+          <a:lstStyle/>
+          <a:p>
+            <a:pPr indent="0" marL="0">
+              <a:buNone/>
+            </a:pPr>
+            <a:r>
+              <a:rPr lang="en-US" sz="1400" b="1" dirty="0">
+                <a:solidFill>
+                  <a:srgbClr val="059669"/>
+                </a:solidFill>
+              </a:rPr>
+              <a:t>✓</a:t>
+            </a:r>
+            <a:endParaRPr lang="en-US" sz="1400" dirty="0"/>
+          </a:p>
+        </p:txBody>
+      </p:sp>
+      <p:sp>
+        <p:nvSpPr>
+          <p:cNvPr id="18" name="Text 16"/>
+          <p:cNvSpPr/>
+          <p:nvPr/>
+        </p:nvSpPr>
+        <p:spPr>
+          <a:xfrm>
+            <a:off x="1024128" y="3977640"/>
+            <a:ext cx="5102352" cy="475488"/>
+          </a:xfrm>
+          <a:prstGeom prst="rect">
+            <a:avLst/>
+          </a:prstGeom>
+          <a:noFill/>
+          <a:ln/>
+        </p:spPr>
+        <p:txBody>
+          <a:bodyPr wrap="square" rtlCol="0" anchor="ctr"/>
+          <a:lstStyle/>
+          <a:p>
+            <a:pPr indent="0" marL="0">
+              <a:buNone/>
+            </a:pPr>
+            <a:r>
+              <a:rPr lang="en-US" sz="1300" dirty="0">
+                <a:solidFill>
+                  <a:srgbClr val="1E1B4B"/>
+                </a:solidFill>
+              </a:rPr>
+              <a:t>Tutor IA del curso</a:t>
+            </a:r>
+            <a:endParaRPr lang="en-US" sz="1300" dirty="0"/>
+          </a:p>
+        </p:txBody>
+      </p:sp>
+      <p:sp>
+        <p:nvSpPr>
+          <p:cNvPr id="19" name="Text 17"/>
+          <p:cNvSpPr/>
+          <p:nvPr/>
+        </p:nvSpPr>
+        <p:spPr>
+          <a:xfrm>
+            <a:off x="640080" y="4453128"/>
+            <a:ext cx="365760" cy="475488"/>
+          </a:xfrm>
+          <a:prstGeom prst="rect">
+            <a:avLst/>
+          </a:prstGeom>
+          <a:noFill/>
+          <a:ln/>
+        </p:spPr>
+        <p:txBody>
+          <a:bodyPr wrap="square" rtlCol="0" anchor="ctr"/>
+          <a:lstStyle/>
+          <a:p>
+            <a:pPr indent="0" marL="0">
+              <a:buNone/>
+            </a:pPr>
+            <a:r>
+              <a:rPr lang="en-US" sz="1400" b="1" dirty="0">
+                <a:solidFill>
+                  <a:srgbClr val="059669"/>
+                </a:solidFill>
+              </a:rPr>
+              <a:t>✓</a:t>
+            </a:r>
+            <a:endParaRPr lang="en-US" sz="1400" dirty="0"/>
+          </a:p>
+        </p:txBody>
+      </p:sp>
+      <p:sp>
+        <p:nvSpPr>
+          <p:cNvPr id="20" name="Text 18"/>
+          <p:cNvSpPr/>
+          <p:nvPr/>
+        </p:nvSpPr>
+        <p:spPr>
+          <a:xfrm>
+            <a:off x="1024128" y="4453128"/>
+            <a:ext cx="5102352" cy="475488"/>
+          </a:xfrm>
+          <a:prstGeom prst="rect">
+            <a:avLst/>
+          </a:prstGeom>
+          <a:noFill/>
+          <a:ln/>
+        </p:spPr>
+        <p:txBody>
+          <a:bodyPr wrap="square" rtlCol="0" anchor="ctr"/>
+          <a:lstStyle/>
+          <a:p>
+            <a:pPr indent="0" marL="0">
+              <a:buNone/>
+            </a:pPr>
+            <a:r>
+              <a:rPr lang="en-US" sz="1300" dirty="0">
+                <a:solidFill>
+                  <a:srgbClr val="1E1B4B"/>
+                </a:solidFill>
+              </a:rPr>
+              <a:t>Detección de copia / antifraude</a:t>
+            </a:r>
+            <a:endParaRPr lang="en-US" sz="1300" dirty="0"/>
+          </a:p>
+        </p:txBody>
+      </p:sp>
+      <p:sp>
+        <p:nvSpPr>
+          <p:cNvPr id="21" name="Text 19"/>
+          <p:cNvSpPr/>
+          <p:nvPr/>
+        </p:nvSpPr>
+        <p:spPr>
+          <a:xfrm>
+            <a:off x="640080" y="4928616"/>
+            <a:ext cx="365760" cy="475488"/>
+          </a:xfrm>
+          <a:prstGeom prst="rect">
+            <a:avLst/>
+          </a:prstGeom>
+          <a:noFill/>
+          <a:ln/>
+        </p:spPr>
+        <p:txBody>
+          <a:bodyPr wrap="square" rtlCol="0" anchor="ctr"/>
+          <a:lstStyle/>
+          <a:p>
+            <a:pPr indent="0" marL="0">
+              <a:buNone/>
+            </a:pPr>
+            <a:r>
+              <a:rPr lang="en-US" sz="1400" b="1" dirty="0">
+                <a:solidFill>
+                  <a:srgbClr val="059669"/>
+                </a:solidFill>
+              </a:rPr>
+              <a:t>✓</a:t>
+            </a:r>
+            <a:endParaRPr lang="en-US" sz="1400" dirty="0"/>
+          </a:p>
+        </p:txBody>
+      </p:sp>
+      <p:sp>
+        <p:nvSpPr>
+          <p:cNvPr id="22" name="Text 20"/>
+          <p:cNvSpPr/>
+          <p:nvPr/>
+        </p:nvSpPr>
+        <p:spPr>
+          <a:xfrm>
+            <a:off x="1024128" y="4928616"/>
+            <a:ext cx="5102352" cy="475488"/>
+          </a:xfrm>
+          <a:prstGeom prst="rect">
+            <a:avLst/>
+          </a:prstGeom>
+          <a:noFill/>
+          <a:ln/>
+        </p:spPr>
+        <p:txBody>
+          <a:bodyPr wrap="square" rtlCol="0" anchor="ctr"/>
+          <a:lstStyle/>
+          <a:p>
+            <a:pPr indent="0" marL="0">
+              <a:buNone/>
+            </a:pPr>
+            <a:r>
+              <a:rPr lang="en-US" sz="1300" dirty="0">
+                <a:solidFill>
+                  <a:srgbClr val="1E1B4B"/>
+                </a:solidFill>
+              </a:rPr>
+              <a:t>Banco de preguntas reutilizable</a:t>
+            </a:r>
+            <a:endParaRPr lang="en-US" sz="1300" dirty="0"/>
+          </a:p>
+        </p:txBody>
+      </p:sp>
+      <p:sp>
+        <p:nvSpPr>
+          <p:cNvPr id="23" name="Text 21"/>
+          <p:cNvSpPr/>
+          <p:nvPr/>
+        </p:nvSpPr>
+        <p:spPr>
+          <a:xfrm>
+            <a:off x="6400800" y="1600200"/>
+            <a:ext cx="365760" cy="475488"/>
+          </a:xfrm>
+          <a:prstGeom prst="rect">
+            <a:avLst/>
+          </a:prstGeom>
+          <a:noFill/>
+          <a:ln/>
+        </p:spPr>
+        <p:txBody>
+          <a:bodyPr wrap="square" rtlCol="0" anchor="ctr"/>
+          <a:lstStyle/>
+          <a:p>
+            <a:pPr indent="0" marL="0">
+              <a:buNone/>
+            </a:pPr>
+            <a:r>
+              <a:rPr lang="en-US" sz="1400" b="1" dirty="0">
+                <a:solidFill>
+                  <a:srgbClr val="059669"/>
+                </a:solidFill>
+              </a:rPr>
+              <a:t>✓</a:t>
+            </a:r>
+            <a:endParaRPr lang="en-US" sz="1400" dirty="0"/>
+          </a:p>
+        </p:txBody>
+      </p:sp>
+      <p:sp>
+        <p:nvSpPr>
+          <p:cNvPr id="24" name="Text 22"/>
+          <p:cNvSpPr/>
+          <p:nvPr/>
+        </p:nvSpPr>
+        <p:spPr>
+          <a:xfrm>
+            <a:off x="6784848" y="1600200"/>
+            <a:ext cx="5102352" cy="475488"/>
+          </a:xfrm>
+          <a:prstGeom prst="rect">
+            <a:avLst/>
+          </a:prstGeom>
+          <a:noFill/>
+          <a:ln/>
+        </p:spPr>
+        <p:txBody>
+          <a:bodyPr wrap="square" rtlCol="0" anchor="ctr"/>
+          <a:lstStyle/>
+          <a:p>
+            <a:pPr indent="0" marL="0">
+              <a:buNone/>
+            </a:pPr>
+            <a:r>
+              <a:rPr lang="en-US" sz="1300" dirty="0">
+                <a:solidFill>
+                  <a:srgbClr val="1E1B4B"/>
+                </a:solidFill>
+              </a:rPr>
+              <a:t>Asistencia con QR (auto check-in)</a:t>
+            </a:r>
+            <a:endParaRPr lang="en-US" sz="1300" dirty="0"/>
+          </a:p>
+        </p:txBody>
+      </p:sp>
+      <p:sp>
+        <p:nvSpPr>
+          <p:cNvPr id="25" name="Text 23"/>
+          <p:cNvSpPr/>
+          <p:nvPr/>
+        </p:nvSpPr>
+        <p:spPr>
+          <a:xfrm>
+            <a:off x="6400800" y="2075688"/>
+            <a:ext cx="365760" cy="475488"/>
+          </a:xfrm>
+          <a:prstGeom prst="rect">
+            <a:avLst/>
+          </a:prstGeom>
+          <a:noFill/>
+          <a:ln/>
+        </p:spPr>
+        <p:txBody>
+          <a:bodyPr wrap="square" rtlCol="0" anchor="ctr"/>
+          <a:lstStyle/>
+          <a:p>
+            <a:pPr indent="0" marL="0">
+              <a:buNone/>
+            </a:pPr>
+            <a:r>
+              <a:rPr lang="en-US" sz="1400" b="1" dirty="0">
+                <a:solidFill>
+                  <a:srgbClr val="059669"/>
+                </a:solidFill>
+              </a:rPr>
+              <a:t>✓</a:t>
+            </a:r>
+            <a:endParaRPr lang="en-US" sz="1400" dirty="0"/>
+          </a:p>
+        </p:txBody>
+      </p:sp>
+      <p:sp>
+        <p:nvSpPr>
+          <p:cNvPr id="26" name="Text 24"/>
+          <p:cNvSpPr/>
+          <p:nvPr/>
+        </p:nvSpPr>
+        <p:spPr>
+          <a:xfrm>
+            <a:off x="6784848" y="2075688"/>
+            <a:ext cx="5102352" cy="475488"/>
+          </a:xfrm>
+          <a:prstGeom prst="rect">
+            <a:avLst/>
+          </a:prstGeom>
+          <a:noFill/>
+          <a:ln/>
+        </p:spPr>
+        <p:txBody>
+          <a:bodyPr wrap="square" rtlCol="0" anchor="ctr"/>
+          <a:lstStyle/>
+          <a:p>
+            <a:pPr indent="0" marL="0">
+              <a:buNone/>
+            </a:pPr>
+            <a:r>
+              <a:rPr lang="en-US" sz="1300" dirty="0">
+                <a:solidFill>
+                  <a:srgbClr val="1E1B4B"/>
+                </a:solidFill>
+              </a:rPr>
+              <a:t>Sincronización con Google/Microsoft Calendar</a:t>
+            </a:r>
+            <a:endParaRPr lang="en-US" sz="1300" dirty="0"/>
+          </a:p>
+        </p:txBody>
+      </p:sp>
+      <p:sp>
+        <p:nvSpPr>
+          <p:cNvPr id="27" name="Text 25"/>
+          <p:cNvSpPr/>
+          <p:nvPr/>
+        </p:nvSpPr>
+        <p:spPr>
+          <a:xfrm>
+            <a:off x="6400800" y="2551176"/>
+            <a:ext cx="365760" cy="475488"/>
+          </a:xfrm>
+          <a:prstGeom prst="rect">
+            <a:avLst/>
+          </a:prstGeom>
+          <a:noFill/>
+          <a:ln/>
+        </p:spPr>
+        <p:txBody>
+          <a:bodyPr wrap="square" rtlCol="0" anchor="ctr"/>
+          <a:lstStyle/>
+          <a:p>
+            <a:pPr indent="0" marL="0">
+              <a:buNone/>
+            </a:pPr>
+            <a:r>
+              <a:rPr lang="en-US" sz="1400" b="1" dirty="0">
+                <a:solidFill>
+                  <a:srgbClr val="059669"/>
+                </a:solidFill>
+              </a:rPr>
+              <a:t>✓</a:t>
+            </a:r>
+            <a:endParaRPr lang="en-US" sz="1400" dirty="0"/>
+          </a:p>
+        </p:txBody>
+      </p:sp>
+      <p:sp>
+        <p:nvSpPr>
+          <p:cNvPr id="28" name="Text 26"/>
+          <p:cNvSpPr/>
+          <p:nvPr/>
+        </p:nvSpPr>
+        <p:spPr>
+          <a:xfrm>
+            <a:off x="6784848" y="2551176"/>
+            <a:ext cx="5102352" cy="475488"/>
+          </a:xfrm>
+          <a:prstGeom prst="rect">
+            <a:avLst/>
+          </a:prstGeom>
+          <a:noFill/>
+          <a:ln/>
+        </p:spPr>
+        <p:txBody>
+          <a:bodyPr wrap="square" rtlCol="0" anchor="ctr"/>
+          <a:lstStyle/>
+          <a:p>
+            <a:pPr indent="0" marL="0">
+              <a:buNone/>
+            </a:pPr>
+            <a:r>
+              <a:rPr lang="en-US" sz="1300" dirty="0">
+                <a:solidFill>
+                  <a:srgbClr val="1E1B4B"/>
+                </a:solidFill>
+              </a:rPr>
+              <a:t>Mensajería, foros y difusión</a:t>
+            </a:r>
+            <a:endParaRPr lang="en-US" sz="1300" dirty="0"/>
+          </a:p>
+        </p:txBody>
+      </p:sp>
+      <p:sp>
+        <p:nvSpPr>
+          <p:cNvPr id="29" name="Text 27"/>
+          <p:cNvSpPr/>
+          <p:nvPr/>
+        </p:nvSpPr>
+        <p:spPr>
+          <a:xfrm>
+            <a:off x="6400800" y="3026664"/>
+            <a:ext cx="365760" cy="475488"/>
+          </a:xfrm>
+          <a:prstGeom prst="rect">
+            <a:avLst/>
+          </a:prstGeom>
+          <a:noFill/>
+          <a:ln/>
+        </p:spPr>
+        <p:txBody>
+          <a:bodyPr wrap="square" rtlCol="0" anchor="ctr"/>
+          <a:lstStyle/>
+          <a:p>
+            <a:pPr indent="0" marL="0">
+              <a:buNone/>
+            </a:pPr>
+            <a:r>
+              <a:rPr lang="en-US" sz="1400" b="1" dirty="0">
+                <a:solidFill>
+                  <a:srgbClr val="059669"/>
+                </a:solidFill>
+              </a:rPr>
+              <a:t>✓</a:t>
+            </a:r>
+            <a:endParaRPr lang="en-US" sz="1400" dirty="0"/>
+          </a:p>
+        </p:txBody>
+      </p:sp>
+      <p:sp>
+        <p:nvSpPr>
+          <p:cNvPr id="30" name="Text 28"/>
+          <p:cNvSpPr/>
+          <p:nvPr/>
+        </p:nvSpPr>
+        <p:spPr>
+          <a:xfrm>
+            <a:off x="6784848" y="3026664"/>
+            <a:ext cx="5102352" cy="475488"/>
+          </a:xfrm>
+          <a:prstGeom prst="rect">
+            <a:avLst/>
+          </a:prstGeom>
+          <a:noFill/>
+          <a:ln/>
+        </p:spPr>
+        <p:txBody>
+          <a:bodyPr wrap="square" rtlCol="0" anchor="ctr"/>
+          <a:lstStyle/>
+          <a:p>
+            <a:pPr indent="0" marL="0">
+              <a:buNone/>
+            </a:pPr>
+            <a:r>
+              <a:rPr lang="en-US" sz="1300" dirty="0">
+                <a:solidFill>
+                  <a:srgbClr val="1E1B4B"/>
+                </a:solidFill>
+              </a:rPr>
+              <a:t>Encuestas y Kahoot en vivo</a:t>
+            </a:r>
+            <a:endParaRPr lang="en-US" sz="1300" dirty="0"/>
+          </a:p>
+        </p:txBody>
+      </p:sp>
+      <p:sp>
+        <p:nvSpPr>
+          <p:cNvPr id="31" name="Text 29"/>
+          <p:cNvSpPr/>
+          <p:nvPr/>
+        </p:nvSpPr>
+        <p:spPr>
+          <a:xfrm>
+            <a:off x="6400800" y="3502152"/>
+            <a:ext cx="365760" cy="475488"/>
+          </a:xfrm>
+          <a:prstGeom prst="rect">
+            <a:avLst/>
+          </a:prstGeom>
+          <a:noFill/>
+          <a:ln/>
+        </p:spPr>
+        <p:txBody>
+          <a:bodyPr wrap="square" rtlCol="0" anchor="ctr"/>
+          <a:lstStyle/>
+          <a:p>
+            <a:pPr indent="0" marL="0">
+              <a:buNone/>
+            </a:pPr>
+            <a:r>
+              <a:rPr lang="en-US" sz="1400" b="1" dirty="0">
+                <a:solidFill>
+                  <a:srgbClr val="059669"/>
+                </a:solidFill>
+              </a:rPr>
+              <a:t>✓</a:t>
+            </a:r>
+            <a:endParaRPr lang="en-US" sz="1400" dirty="0"/>
+          </a:p>
+        </p:txBody>
+      </p:sp>
+      <p:sp>
+        <p:nvSpPr>
+          <p:cNvPr id="32" name="Text 30"/>
+          <p:cNvSpPr/>
+          <p:nvPr/>
+        </p:nvSpPr>
+        <p:spPr>
+          <a:xfrm>
+            <a:off x="6784848" y="3502152"/>
+            <a:ext cx="5102352" cy="475488"/>
+          </a:xfrm>
+          <a:prstGeom prst="rect">
+            <a:avLst/>
+          </a:prstGeom>
+          <a:noFill/>
+          <a:ln/>
+        </p:spPr>
+        <p:txBody>
+          <a:bodyPr wrap="square" rtlCol="0" anchor="ctr"/>
+          <a:lstStyle/>
+          <a:p>
+            <a:pPr indent="0" marL="0">
+              <a:buNone/>
+            </a:pPr>
+            <a:r>
+              <a:rPr lang="en-US" sz="1300" dirty="0">
+                <a:solidFill>
+                  <a:srgbClr val="1E1B4B"/>
+                </a:solidFill>
+              </a:rPr>
+              <a:t>Certificados, reportes y libro de calificaciones</a:t>
+            </a:r>
+            <a:endParaRPr lang="en-US" sz="1300" dirty="0"/>
+          </a:p>
+        </p:txBody>
+      </p:sp>
+      <p:sp>
+        <p:nvSpPr>
+          <p:cNvPr id="33" name="Text 31"/>
+          <p:cNvSpPr/>
+          <p:nvPr/>
+        </p:nvSpPr>
+        <p:spPr>
+          <a:xfrm>
+            <a:off x="6400800" y="3977640"/>
+            <a:ext cx="365760" cy="475488"/>
+          </a:xfrm>
+          <a:prstGeom prst="rect">
+            <a:avLst/>
+          </a:prstGeom>
+          <a:noFill/>
+          <a:ln/>
+        </p:spPr>
+        <p:txBody>
+          <a:bodyPr wrap="square" rtlCol="0" anchor="ctr"/>
+          <a:lstStyle/>
+          <a:p>
+            <a:pPr indent="0" marL="0">
+              <a:buNone/>
+            </a:pPr>
+            <a:r>
+              <a:rPr lang="en-US" sz="1400" b="1" dirty="0">
+                <a:solidFill>
+                  <a:srgbClr val="059669"/>
+                </a:solidFill>
+              </a:rPr>
+              <a:t>✓</a:t>
+            </a:r>
+            <a:endParaRPr lang="en-US" sz="1400" dirty="0"/>
+          </a:p>
+        </p:txBody>
+      </p:sp>
+      <p:sp>
+        <p:nvSpPr>
+          <p:cNvPr id="34" name="Text 32"/>
+          <p:cNvSpPr/>
+          <p:nvPr/>
+        </p:nvSpPr>
+        <p:spPr>
+          <a:xfrm>
+            <a:off x="6784848" y="3977640"/>
+            <a:ext cx="5102352" cy="475488"/>
+          </a:xfrm>
+          <a:prstGeom prst="rect">
+            <a:avLst/>
+          </a:prstGeom>
+          <a:noFill/>
+          <a:ln/>
+        </p:spPr>
+        <p:txBody>
+          <a:bodyPr wrap="square" rtlCol="0" anchor="ctr"/>
+          <a:lstStyle/>
+          <a:p>
+            <a:pPr indent="0" marL="0">
+              <a:buNone/>
+            </a:pPr>
+            <a:r>
+              <a:rPr lang="en-US" sz="1300" dirty="0">
+                <a:solidFill>
+                  <a:srgbClr val="1E1B4B"/>
+                </a:solidFill>
+              </a:rPr>
+              <a:t>Ejecución de código (Java/Python) en línea</a:t>
+            </a:r>
+            <a:endParaRPr lang="en-US" sz="1300" dirty="0"/>
+          </a:p>
+        </p:txBody>
+      </p:sp>
+      <p:sp>
+        <p:nvSpPr>
+          <p:cNvPr id="35" name="Text 33"/>
+          <p:cNvSpPr/>
+          <p:nvPr/>
+        </p:nvSpPr>
+        <p:spPr>
+          <a:xfrm>
+            <a:off x="6400800" y="4453128"/>
+            <a:ext cx="365760" cy="475488"/>
+          </a:xfrm>
+          <a:prstGeom prst="rect">
+            <a:avLst/>
+          </a:prstGeom>
+          <a:noFill/>
+          <a:ln/>
+        </p:spPr>
+        <p:txBody>
+          <a:bodyPr wrap="square" rtlCol="0" anchor="ctr"/>
+          <a:lstStyle/>
+          <a:p>
+            <a:pPr indent="0" marL="0">
+              <a:buNone/>
+            </a:pPr>
+            <a:r>
+              <a:rPr lang="en-US" sz="1400" b="1" dirty="0">
+                <a:solidFill>
+                  <a:srgbClr val="059669"/>
+                </a:solidFill>
+              </a:rPr>
+              <a:t>✓</a:t>
+            </a:r>
+            <a:endParaRPr lang="en-US" sz="1400" dirty="0"/>
+          </a:p>
+        </p:txBody>
+      </p:sp>
+      <p:sp>
+        <p:nvSpPr>
+          <p:cNvPr id="36" name="Text 34"/>
+          <p:cNvSpPr/>
+          <p:nvPr/>
+        </p:nvSpPr>
+        <p:spPr>
+          <a:xfrm>
+            <a:off x="6784848" y="4453128"/>
+            <a:ext cx="5102352" cy="475488"/>
+          </a:xfrm>
+          <a:prstGeom prst="rect">
+            <a:avLst/>
+          </a:prstGeom>
+          <a:noFill/>
+          <a:ln/>
+        </p:spPr>
+        <p:txBody>
+          <a:bodyPr wrap="square" rtlCol="0" anchor="ctr"/>
+          <a:lstStyle/>
+          <a:p>
+            <a:pPr indent="0" marL="0">
+              <a:buNone/>
+            </a:pPr>
+            <a:r>
+              <a:rPr lang="en-US" sz="1300" dirty="0">
+                <a:solidFill>
+                  <a:srgbClr val="1E1B4B"/>
+                </a:solidFill>
+              </a:rPr>
+              <a:t>Multi-sede, branding y auditoría</a:t>
+            </a:r>
+            <a:endParaRPr lang="en-US" sz="1300" dirty="0"/>
+          </a:p>
+        </p:txBody>
+      </p:sp>
+      <p:sp>
+        <p:nvSpPr>
+          <p:cNvPr id="37" name="Text 35"/>
+          <p:cNvSpPr/>
+          <p:nvPr/>
+        </p:nvSpPr>
+        <p:spPr>
+          <a:xfrm>
+            <a:off x="6400800" y="4928616"/>
+            <a:ext cx="365760" cy="475488"/>
+          </a:xfrm>
+          <a:prstGeom prst="rect">
+            <a:avLst/>
+          </a:prstGeom>
+          <a:noFill/>
+          <a:ln/>
+        </p:spPr>
+        <p:txBody>
+          <a:bodyPr wrap="square" rtlCol="0" anchor="ctr"/>
+          <a:lstStyle/>
+          <a:p>
+            <a:pPr indent="0" marL="0">
+              <a:buNone/>
+            </a:pPr>
+            <a:r>
+              <a:rPr lang="en-US" sz="1400" b="1" dirty="0">
+                <a:solidFill>
+                  <a:srgbClr val="059669"/>
+                </a:solidFill>
+              </a:rPr>
+              <a:t>✓</a:t>
+            </a:r>
+            <a:endParaRPr lang="en-US" sz="1400" dirty="0"/>
+          </a:p>
+        </p:txBody>
+      </p:sp>
+      <p:sp>
+        <p:nvSpPr>
+          <p:cNvPr id="38" name="Text 36"/>
+          <p:cNvSpPr/>
+          <p:nvPr/>
+        </p:nvSpPr>
+        <p:spPr>
+          <a:xfrm>
+            <a:off x="6784848" y="4928616"/>
+            <a:ext cx="5102352" cy="475488"/>
+          </a:xfrm>
+          <a:prstGeom prst="rect">
+            <a:avLst/>
+          </a:prstGeom>
+          <a:noFill/>
+          <a:ln/>
+        </p:spPr>
+        <p:txBody>
+          <a:bodyPr wrap="square" rtlCol="0" anchor="ctr"/>
+          <a:lstStyle/>
+          <a:p>
+            <a:pPr indent="0" marL="0">
+              <a:buNone/>
+            </a:pPr>
+            <a:r>
+              <a:rPr lang="en-US" sz="1300" dirty="0">
+                <a:solidFill>
+                  <a:srgbClr val="1E1B4B"/>
+                </a:solidFill>
+              </a:rPr>
+              <a:t>Notificaciones en la app y push</a:t>
+            </a:r>
+            <a:endParaRPr lang="en-US" sz="1300" dirty="0"/>
+          </a:p>
+        </p:txBody>
+      </p:sp>
+      <p:sp>
+        <p:nvSpPr>
+          <p:cNvPr id="39" name="Shape 37"/>
+          <p:cNvSpPr/>
+          <p:nvPr/>
+        </p:nvSpPr>
+        <p:spPr>
+          <a:xfrm>
+            <a:off x="640080" y="5989320"/>
+            <a:ext cx="10881360" cy="566928"/>
+          </a:xfrm>
+          <a:prstGeom prst="roundRect">
+            <a:avLst>
+              <a:gd name="adj" fmla="val 12903"/>
+            </a:avLst>
           </a:prstGeom>
           <a:solidFill>
-            <a:srgbClr val="1E1B4B"/>
+            <a:srgbClr val="ECFDF5"/>
           </a:solidFill>
-          <a:ln/>
-        </p:spPr>
-      </p:sp>
-      <p:sp>
-        <p:nvSpPr>
-          <p:cNvPr id="6" name="Text 4"/>
-          <p:cNvSpPr/>
-          <p:nvPr/>
-        </p:nvSpPr>
-        <p:spPr>
-          <a:xfrm>
-            <a:off x="548640" y="1325880"/>
-            <a:ext cx="5943600" cy="457200"/>
-          </a:xfrm>
-          <a:prstGeom prst="rect">
-            <a:avLst/>
-          </a:prstGeom>
-          <a:noFill/>
-          <a:ln/>
-        </p:spPr>
-        <p:txBody>
-          <a:bodyPr wrap="square" rtlCol="0" anchor="ctr"/>
-          <a:lstStyle/>
-          <a:p>
-            <a:pPr algn="l" indent="0" marL="0">
-              <a:buNone/>
-            </a:pPr>
-            <a:r>
-              <a:rPr lang="en-US" sz="1250" b="1" dirty="0">
-                <a:solidFill>
-                  <a:srgbClr val="FFFFFF"/>
-                </a:solidFill>
-              </a:rPr>
-              <a:t>Característica</a:t>
-            </a:r>
-            <a:endParaRPr lang="en-US" sz="1250" dirty="0"/>
-          </a:p>
-        </p:txBody>
-      </p:sp>
-      <p:sp>
-        <p:nvSpPr>
-          <p:cNvPr id="7" name="Text 5"/>
-          <p:cNvSpPr/>
-          <p:nvPr/>
-        </p:nvSpPr>
-        <p:spPr>
-          <a:xfrm>
-            <a:off x="6583680" y="1325880"/>
-            <a:ext cx="1828800" cy="457200"/>
-          </a:xfrm>
-          <a:prstGeom prst="rect">
-            <a:avLst/>
-          </a:prstGeom>
-          <a:noFill/>
-          <a:ln/>
-        </p:spPr>
-        <p:txBody>
-          <a:bodyPr wrap="square" rtlCol="0" anchor="ctr"/>
-          <a:lstStyle/>
-          <a:p>
-            <a:pPr algn="ctr" indent="0" marL="0">
-              <a:buNone/>
-            </a:pPr>
-            <a:r>
-              <a:rPr lang="en-US" sz="1250" b="1" dirty="0">
-                <a:solidFill>
-                  <a:srgbClr val="FFFFFF"/>
-                </a:solidFill>
-              </a:rPr>
-              <a:t>Esencial</a:t>
-            </a:r>
-            <a:endParaRPr lang="en-US" sz="1250" dirty="0"/>
-          </a:p>
-        </p:txBody>
-      </p:sp>
-      <p:sp>
-        <p:nvSpPr>
-          <p:cNvPr id="8" name="Text 6"/>
-          <p:cNvSpPr/>
-          <p:nvPr/>
-        </p:nvSpPr>
-        <p:spPr>
-          <a:xfrm>
-            <a:off x="8458200" y="1325880"/>
-            <a:ext cx="1828800" cy="457200"/>
-          </a:xfrm>
-          <a:prstGeom prst="rect">
-            <a:avLst/>
-          </a:prstGeom>
-          <a:noFill/>
-          <a:ln/>
-        </p:spPr>
-        <p:txBody>
-          <a:bodyPr wrap="square" rtlCol="0" anchor="ctr"/>
-          <a:lstStyle/>
-          <a:p>
-            <a:pPr algn="ctr" indent="0" marL="0">
-              <a:buNone/>
-            </a:pPr>
-            <a:r>
-              <a:rPr lang="en-US" sz="1250" b="1" dirty="0">
-                <a:solidFill>
-                  <a:srgbClr val="FFFFFF"/>
-                </a:solidFill>
-              </a:rPr>
-              <a:t>Profesional</a:t>
-            </a:r>
-            <a:endParaRPr lang="en-US" sz="1250" dirty="0"/>
-          </a:p>
-        </p:txBody>
-      </p:sp>
-      <p:sp>
-        <p:nvSpPr>
-          <p:cNvPr id="9" name="Text 7"/>
-          <p:cNvSpPr/>
-          <p:nvPr/>
-        </p:nvSpPr>
-        <p:spPr>
-          <a:xfrm>
-            <a:off x="10332720" y="1325880"/>
-            <a:ext cx="1828800" cy="457200"/>
-          </a:xfrm>
-          <a:prstGeom prst="rect">
-            <a:avLst/>
-          </a:prstGeom>
-          <a:noFill/>
-          <a:ln/>
-        </p:spPr>
-        <p:txBody>
-          <a:bodyPr wrap="square" rtlCol="0" anchor="ctr"/>
-          <a:lstStyle/>
-          <a:p>
-            <a:pPr algn="ctr" indent="0" marL="0">
-              <a:buNone/>
-            </a:pPr>
-            <a:r>
-              <a:rPr lang="en-US" sz="1250" b="1" dirty="0">
-                <a:solidFill>
-                  <a:srgbClr val="FFFFFF"/>
-                </a:solidFill>
-              </a:rPr>
-              <a:t>Institucional</a:t>
-            </a:r>
-            <a:endParaRPr lang="en-US" sz="1250" dirty="0"/>
-          </a:p>
-        </p:txBody>
-      </p:sp>
-      <p:sp>
-        <p:nvSpPr>
-          <p:cNvPr id="10" name="Text 8"/>
-          <p:cNvSpPr/>
-          <p:nvPr/>
-        </p:nvSpPr>
-        <p:spPr>
-          <a:xfrm>
-            <a:off x="548640" y="1783080"/>
-            <a:ext cx="5943600" cy="457200"/>
-          </a:xfrm>
-          <a:prstGeom prst="rect">
-            <a:avLst/>
-          </a:prstGeom>
-          <a:noFill/>
-          <a:ln/>
-        </p:spPr>
-        <p:txBody>
-          <a:bodyPr wrap="square" rtlCol="0" anchor="ctr"/>
-          <a:lstStyle/>
-          <a:p>
-            <a:pPr algn="l" indent="0" marL="0">
-              <a:buNone/>
-            </a:pPr>
-            <a:r>
-              <a:rPr lang="en-US" sz="1200" b="1" dirty="0">
+          <a:ln w="12700">
+            <a:solidFill>
+              <a:srgbClr val="059669"/>
+            </a:solidFill>
+            <a:prstDash val="solid"/>
+          </a:ln>
+        </p:spPr>
+      </p:sp>
+      <p:sp>
+        <p:nvSpPr>
+          <p:cNvPr id="40" name="Text 38"/>
+          <p:cNvSpPr/>
+          <p:nvPr/>
+        </p:nvSpPr>
+        <p:spPr>
+          <a:xfrm>
+            <a:off x="868680" y="5989320"/>
+            <a:ext cx="10424160" cy="566928"/>
+          </a:xfrm>
+          <a:prstGeom prst="rect">
+            <a:avLst/>
+          </a:prstGeom>
+          <a:noFill/>
+          <a:ln/>
+        </p:spPr>
+        <p:txBody>
+          <a:bodyPr wrap="square" rtlCol="0" anchor="ctr"/>
+          <a:lstStyle/>
+          <a:p>
+            <a:pPr indent="0" marL="0">
+              <a:buNone/>
+            </a:pPr>
+            <a:r>
+              <a:rPr lang="en-US" sz="1300" b="1" dirty="0">
+                <a:solidFill>
+                  <a:srgbClr val="059669"/>
+                </a:solidFill>
+              </a:rPr>
+              <a:t>✨  </a:t>
+            </a:r>
+            <a:pPr indent="0" marL="0">
+              <a:buNone/>
+            </a:pPr>
+            <a:r>
+              <a:rPr lang="en-US" sz="1250" i="1" dirty="0">
                 <a:solidFill>
                   <a:srgbClr val="1E1B4B"/>
                 </a:solidFill>
               </a:rPr>
-              <a:t>Cursos, exámenes, talleres y proyectos</a:t>
-            </a:r>
-            <a:endParaRPr lang="en-US" sz="1200" dirty="0"/>
-          </a:p>
-        </p:txBody>
-      </p:sp>
-      <p:sp>
-        <p:nvSpPr>
-          <p:cNvPr id="11" name="Text 9"/>
-          <p:cNvSpPr/>
-          <p:nvPr/>
-        </p:nvSpPr>
-        <p:spPr>
-          <a:xfrm>
-            <a:off x="6583680" y="1783080"/>
-            <a:ext cx="1828800" cy="457200"/>
-          </a:xfrm>
-          <a:prstGeom prst="rect">
-            <a:avLst/>
-          </a:prstGeom>
-          <a:noFill/>
-          <a:ln/>
-        </p:spPr>
-        <p:txBody>
-          <a:bodyPr wrap="square" rtlCol="0" anchor="ctr"/>
-          <a:lstStyle/>
-          <a:p>
-            <a:pPr algn="ctr" indent="0" marL="0">
-              <a:buNone/>
-            </a:pPr>
-            <a:r>
-              <a:rPr lang="en-US" sz="1200" dirty="0">
-                <a:solidFill>
-                  <a:srgbClr val="059669"/>
-                </a:solidFill>
-              </a:rPr>
-              <a:t>✓</a:t>
-            </a:r>
-            <a:endParaRPr lang="en-US" sz="1200" dirty="0"/>
-          </a:p>
-        </p:txBody>
-      </p:sp>
-      <p:sp>
-        <p:nvSpPr>
-          <p:cNvPr id="12" name="Text 10"/>
-          <p:cNvSpPr/>
-          <p:nvPr/>
-        </p:nvSpPr>
-        <p:spPr>
-          <a:xfrm>
-            <a:off x="8458200" y="1783080"/>
-            <a:ext cx="1828800" cy="457200"/>
-          </a:xfrm>
-          <a:prstGeom prst="rect">
-            <a:avLst/>
-          </a:prstGeom>
-          <a:noFill/>
-          <a:ln/>
-        </p:spPr>
-        <p:txBody>
-          <a:bodyPr wrap="square" rtlCol="0" anchor="ctr"/>
-          <a:lstStyle/>
-          <a:p>
-            <a:pPr algn="ctr" indent="0" marL="0">
-              <a:buNone/>
-            </a:pPr>
-            <a:r>
-              <a:rPr lang="en-US" sz="1200" dirty="0">
-                <a:solidFill>
-                  <a:srgbClr val="059669"/>
-                </a:solidFill>
-              </a:rPr>
-              <a:t>✓</a:t>
-            </a:r>
-            <a:endParaRPr lang="en-US" sz="1200" dirty="0"/>
-          </a:p>
-        </p:txBody>
-      </p:sp>
-      <p:sp>
-        <p:nvSpPr>
-          <p:cNvPr id="13" name="Text 11"/>
-          <p:cNvSpPr/>
-          <p:nvPr/>
-        </p:nvSpPr>
-        <p:spPr>
-          <a:xfrm>
-            <a:off x="10332720" y="1783080"/>
-            <a:ext cx="1828800" cy="457200"/>
-          </a:xfrm>
-          <a:prstGeom prst="rect">
-            <a:avLst/>
-          </a:prstGeom>
-          <a:noFill/>
-          <a:ln/>
-        </p:spPr>
-        <p:txBody>
-          <a:bodyPr wrap="square" rtlCol="0" anchor="ctr"/>
-          <a:lstStyle/>
-          <a:p>
-            <a:pPr algn="ctr" indent="0" marL="0">
-              <a:buNone/>
-            </a:pPr>
-            <a:r>
-              <a:rPr lang="en-US" sz="1200" dirty="0">
-                <a:solidFill>
-                  <a:srgbClr val="059669"/>
-                </a:solidFill>
-              </a:rPr>
-              <a:t>✓</a:t>
-            </a:r>
-            <a:endParaRPr lang="en-US" sz="1200" dirty="0"/>
-          </a:p>
-        </p:txBody>
-      </p:sp>
-      <p:sp>
-        <p:nvSpPr>
-          <p:cNvPr id="14" name="Shape 12"/>
-          <p:cNvSpPr/>
-          <p:nvPr/>
-        </p:nvSpPr>
-        <p:spPr>
-          <a:xfrm>
-            <a:off x="457200" y="2240280"/>
-            <a:ext cx="11338560" cy="457200"/>
+              <a:t>El API key de IA lo pones tú: usas tu propia cuenta de IA, sin sobrecosto de uso en la suscripción.</a:t>
+            </a:r>
+            <a:endParaRPr lang="en-US" sz="1300" dirty="0"/>
+          </a:p>
+        </p:txBody>
+      </p:sp>
+      <p:sp>
+        <p:nvSpPr>
+          <p:cNvPr id="41" name="Shape 39"/>
+          <p:cNvSpPr/>
+          <p:nvPr/>
+        </p:nvSpPr>
+        <p:spPr>
+          <a:xfrm>
+            <a:off x="0" y="6565392"/>
+            <a:ext cx="12191695" cy="292608"/>
           </a:xfrm>
           <a:prstGeom prst="rect">
             <a:avLst/>
@@ -4500,1239 +5510,7 @@
       </p:sp>
       <p:sp>
         <p:nvSpPr>
-          <p:cNvPr id="15" name="Text 13"/>
-          <p:cNvSpPr/>
-          <p:nvPr/>
-        </p:nvSpPr>
-        <p:spPr>
-          <a:xfrm>
-            <a:off x="548640" y="2240280"/>
-            <a:ext cx="5943600" cy="457200"/>
-          </a:xfrm>
-          <a:prstGeom prst="rect">
-            <a:avLst/>
-          </a:prstGeom>
-          <a:noFill/>
-          <a:ln/>
-        </p:spPr>
-        <p:txBody>
-          <a:bodyPr wrap="square" rtlCol="0" anchor="ctr"/>
-          <a:lstStyle/>
-          <a:p>
-            <a:pPr algn="l" indent="0" marL="0">
-              <a:buNone/>
-            </a:pPr>
-            <a:r>
-              <a:rPr lang="en-US" sz="1200" b="1" dirty="0">
-                <a:solidFill>
-                  <a:srgbClr val="1E1B4B"/>
-                </a:solidFill>
-              </a:rPr>
-              <a:t>IA: generación de evaluaciones y contenido</a:t>
-            </a:r>
-            <a:endParaRPr lang="en-US" sz="1200" dirty="0"/>
-          </a:p>
-        </p:txBody>
-      </p:sp>
-      <p:sp>
-        <p:nvSpPr>
-          <p:cNvPr id="16" name="Text 14"/>
-          <p:cNvSpPr/>
-          <p:nvPr/>
-        </p:nvSpPr>
-        <p:spPr>
-          <a:xfrm>
-            <a:off x="6583680" y="2240280"/>
-            <a:ext cx="1828800" cy="457200"/>
-          </a:xfrm>
-          <a:prstGeom prst="rect">
-            <a:avLst/>
-          </a:prstGeom>
-          <a:noFill/>
-          <a:ln/>
-        </p:spPr>
-        <p:txBody>
-          <a:bodyPr wrap="square" rtlCol="0" anchor="ctr"/>
-          <a:lstStyle/>
-          <a:p>
-            <a:pPr algn="ctr" indent="0" marL="0">
-              <a:buNone/>
-            </a:pPr>
-            <a:r>
-              <a:rPr lang="en-US" sz="1200" dirty="0">
-                <a:solidFill>
-                  <a:srgbClr val="059669"/>
-                </a:solidFill>
-              </a:rPr>
-              <a:t>✓</a:t>
-            </a:r>
-            <a:endParaRPr lang="en-US" sz="1200" dirty="0"/>
-          </a:p>
-        </p:txBody>
-      </p:sp>
-      <p:sp>
-        <p:nvSpPr>
-          <p:cNvPr id="17" name="Text 15"/>
-          <p:cNvSpPr/>
-          <p:nvPr/>
-        </p:nvSpPr>
-        <p:spPr>
-          <a:xfrm>
-            <a:off x="8458200" y="2240280"/>
-            <a:ext cx="1828800" cy="457200"/>
-          </a:xfrm>
-          <a:prstGeom prst="rect">
-            <a:avLst/>
-          </a:prstGeom>
-          <a:noFill/>
-          <a:ln/>
-        </p:spPr>
-        <p:txBody>
-          <a:bodyPr wrap="square" rtlCol="0" anchor="ctr"/>
-          <a:lstStyle/>
-          <a:p>
-            <a:pPr algn="ctr" indent="0" marL="0">
-              <a:buNone/>
-            </a:pPr>
-            <a:r>
-              <a:rPr lang="en-US" sz="1200" dirty="0">
-                <a:solidFill>
-                  <a:srgbClr val="059669"/>
-                </a:solidFill>
-              </a:rPr>
-              <a:t>✓</a:t>
-            </a:r>
-            <a:endParaRPr lang="en-US" sz="1200" dirty="0"/>
-          </a:p>
-        </p:txBody>
-      </p:sp>
-      <p:sp>
-        <p:nvSpPr>
-          <p:cNvPr id="18" name="Text 16"/>
-          <p:cNvSpPr/>
-          <p:nvPr/>
-        </p:nvSpPr>
-        <p:spPr>
-          <a:xfrm>
-            <a:off x="10332720" y="2240280"/>
-            <a:ext cx="1828800" cy="457200"/>
-          </a:xfrm>
-          <a:prstGeom prst="rect">
-            <a:avLst/>
-          </a:prstGeom>
-          <a:noFill/>
-          <a:ln/>
-        </p:spPr>
-        <p:txBody>
-          <a:bodyPr wrap="square" rtlCol="0" anchor="ctr"/>
-          <a:lstStyle/>
-          <a:p>
-            <a:pPr algn="ctr" indent="0" marL="0">
-              <a:buNone/>
-            </a:pPr>
-            <a:r>
-              <a:rPr lang="en-US" sz="1200" dirty="0">
-                <a:solidFill>
-                  <a:srgbClr val="059669"/>
-                </a:solidFill>
-              </a:rPr>
-              <a:t>✓</a:t>
-            </a:r>
-            <a:endParaRPr lang="en-US" sz="1200" dirty="0"/>
-          </a:p>
-        </p:txBody>
-      </p:sp>
-      <p:sp>
-        <p:nvSpPr>
-          <p:cNvPr id="19" name="Text 17"/>
-          <p:cNvSpPr/>
-          <p:nvPr/>
-        </p:nvSpPr>
-        <p:spPr>
-          <a:xfrm>
-            <a:off x="548640" y="2697480"/>
-            <a:ext cx="5943600" cy="457200"/>
-          </a:xfrm>
-          <a:prstGeom prst="rect">
-            <a:avLst/>
-          </a:prstGeom>
-          <a:noFill/>
-          <a:ln/>
-        </p:spPr>
-        <p:txBody>
-          <a:bodyPr wrap="square" rtlCol="0" anchor="ctr"/>
-          <a:lstStyle/>
-          <a:p>
-            <a:pPr algn="l" indent="0" marL="0">
-              <a:buNone/>
-            </a:pPr>
-            <a:r>
-              <a:rPr lang="en-US" sz="1200" b="1" dirty="0">
-                <a:solidFill>
-                  <a:srgbClr val="1E1B4B"/>
-                </a:solidFill>
-              </a:rPr>
-              <a:t>IA: calificación automática con feedback</a:t>
-            </a:r>
-            <a:endParaRPr lang="en-US" sz="1200" dirty="0"/>
-          </a:p>
-        </p:txBody>
-      </p:sp>
-      <p:sp>
-        <p:nvSpPr>
-          <p:cNvPr id="20" name="Text 18"/>
-          <p:cNvSpPr/>
-          <p:nvPr/>
-        </p:nvSpPr>
-        <p:spPr>
-          <a:xfrm>
-            <a:off x="6583680" y="2697480"/>
-            <a:ext cx="1828800" cy="457200"/>
-          </a:xfrm>
-          <a:prstGeom prst="rect">
-            <a:avLst/>
-          </a:prstGeom>
-          <a:noFill/>
-          <a:ln/>
-        </p:spPr>
-        <p:txBody>
-          <a:bodyPr wrap="square" rtlCol="0" anchor="ctr"/>
-          <a:lstStyle/>
-          <a:p>
-            <a:pPr algn="ctr" indent="0" marL="0">
-              <a:buNone/>
-            </a:pPr>
-            <a:r>
-              <a:rPr lang="en-US" sz="1200" dirty="0">
-                <a:solidFill>
-                  <a:srgbClr val="059669"/>
-                </a:solidFill>
-              </a:rPr>
-              <a:t>✓</a:t>
-            </a:r>
-            <a:endParaRPr lang="en-US" sz="1200" dirty="0"/>
-          </a:p>
-        </p:txBody>
-      </p:sp>
-      <p:sp>
-        <p:nvSpPr>
-          <p:cNvPr id="21" name="Text 19"/>
-          <p:cNvSpPr/>
-          <p:nvPr/>
-        </p:nvSpPr>
-        <p:spPr>
-          <a:xfrm>
-            <a:off x="8458200" y="2697480"/>
-            <a:ext cx="1828800" cy="457200"/>
-          </a:xfrm>
-          <a:prstGeom prst="rect">
-            <a:avLst/>
-          </a:prstGeom>
-          <a:noFill/>
-          <a:ln/>
-        </p:spPr>
-        <p:txBody>
-          <a:bodyPr wrap="square" rtlCol="0" anchor="ctr"/>
-          <a:lstStyle/>
-          <a:p>
-            <a:pPr algn="ctr" indent="0" marL="0">
-              <a:buNone/>
-            </a:pPr>
-            <a:r>
-              <a:rPr lang="en-US" sz="1200" dirty="0">
-                <a:solidFill>
-                  <a:srgbClr val="059669"/>
-                </a:solidFill>
-              </a:rPr>
-              <a:t>✓</a:t>
-            </a:r>
-            <a:endParaRPr lang="en-US" sz="1200" dirty="0"/>
-          </a:p>
-        </p:txBody>
-      </p:sp>
-      <p:sp>
-        <p:nvSpPr>
-          <p:cNvPr id="22" name="Text 20"/>
-          <p:cNvSpPr/>
-          <p:nvPr/>
-        </p:nvSpPr>
-        <p:spPr>
-          <a:xfrm>
-            <a:off x="10332720" y="2697480"/>
-            <a:ext cx="1828800" cy="457200"/>
-          </a:xfrm>
-          <a:prstGeom prst="rect">
-            <a:avLst/>
-          </a:prstGeom>
-          <a:noFill/>
-          <a:ln/>
-        </p:spPr>
-        <p:txBody>
-          <a:bodyPr wrap="square" rtlCol="0" anchor="ctr"/>
-          <a:lstStyle/>
-          <a:p>
-            <a:pPr algn="ctr" indent="0" marL="0">
-              <a:buNone/>
-            </a:pPr>
-            <a:r>
-              <a:rPr lang="en-US" sz="1200" dirty="0">
-                <a:solidFill>
-                  <a:srgbClr val="059669"/>
-                </a:solidFill>
-              </a:rPr>
-              <a:t>✓</a:t>
-            </a:r>
-            <a:endParaRPr lang="en-US" sz="1200" dirty="0"/>
-          </a:p>
-        </p:txBody>
-      </p:sp>
-      <p:sp>
-        <p:nvSpPr>
-          <p:cNvPr id="23" name="Shape 21"/>
-          <p:cNvSpPr/>
-          <p:nvPr/>
-        </p:nvSpPr>
-        <p:spPr>
-          <a:xfrm>
-            <a:off x="457200" y="3154680"/>
-            <a:ext cx="11338560" cy="457200"/>
-          </a:xfrm>
-          <a:prstGeom prst="rect">
-            <a:avLst/>
-          </a:prstGeom>
-          <a:solidFill>
-            <a:srgbClr val="F5F3FF"/>
-          </a:solidFill>
-          <a:ln/>
-        </p:spPr>
-      </p:sp>
-      <p:sp>
-        <p:nvSpPr>
-          <p:cNvPr id="24" name="Text 22"/>
-          <p:cNvSpPr/>
-          <p:nvPr/>
-        </p:nvSpPr>
-        <p:spPr>
-          <a:xfrm>
-            <a:off x="548640" y="3154680"/>
-            <a:ext cx="5943600" cy="457200"/>
-          </a:xfrm>
-          <a:prstGeom prst="rect">
-            <a:avLst/>
-          </a:prstGeom>
-          <a:noFill/>
-          <a:ln/>
-        </p:spPr>
-        <p:txBody>
-          <a:bodyPr wrap="square" rtlCol="0" anchor="ctr"/>
-          <a:lstStyle/>
-          <a:p>
-            <a:pPr algn="l" indent="0" marL="0">
-              <a:buNone/>
-            </a:pPr>
-            <a:r>
-              <a:rPr lang="en-US" sz="1200" b="1" dirty="0">
-                <a:solidFill>
-                  <a:srgbClr val="1E1B4B"/>
-                </a:solidFill>
-              </a:rPr>
-              <a:t>Asistencia con QR y mensajería</a:t>
-            </a:r>
-            <a:endParaRPr lang="en-US" sz="1200" dirty="0"/>
-          </a:p>
-        </p:txBody>
-      </p:sp>
-      <p:sp>
-        <p:nvSpPr>
-          <p:cNvPr id="25" name="Text 23"/>
-          <p:cNvSpPr/>
-          <p:nvPr/>
-        </p:nvSpPr>
-        <p:spPr>
-          <a:xfrm>
-            <a:off x="6583680" y="3154680"/>
-            <a:ext cx="1828800" cy="457200"/>
-          </a:xfrm>
-          <a:prstGeom prst="rect">
-            <a:avLst/>
-          </a:prstGeom>
-          <a:noFill/>
-          <a:ln/>
-        </p:spPr>
-        <p:txBody>
-          <a:bodyPr wrap="square" rtlCol="0" anchor="ctr"/>
-          <a:lstStyle/>
-          <a:p>
-            <a:pPr algn="ctr" indent="0" marL="0">
-              <a:buNone/>
-            </a:pPr>
-            <a:r>
-              <a:rPr lang="en-US" sz="1200" dirty="0">
-                <a:solidFill>
-                  <a:srgbClr val="059669"/>
-                </a:solidFill>
-              </a:rPr>
-              <a:t>✓</a:t>
-            </a:r>
-            <a:endParaRPr lang="en-US" sz="1200" dirty="0"/>
-          </a:p>
-        </p:txBody>
-      </p:sp>
-      <p:sp>
-        <p:nvSpPr>
-          <p:cNvPr id="26" name="Text 24"/>
-          <p:cNvSpPr/>
-          <p:nvPr/>
-        </p:nvSpPr>
-        <p:spPr>
-          <a:xfrm>
-            <a:off x="8458200" y="3154680"/>
-            <a:ext cx="1828800" cy="457200"/>
-          </a:xfrm>
-          <a:prstGeom prst="rect">
-            <a:avLst/>
-          </a:prstGeom>
-          <a:noFill/>
-          <a:ln/>
-        </p:spPr>
-        <p:txBody>
-          <a:bodyPr wrap="square" rtlCol="0" anchor="ctr"/>
-          <a:lstStyle/>
-          <a:p>
-            <a:pPr algn="ctr" indent="0" marL="0">
-              <a:buNone/>
-            </a:pPr>
-            <a:r>
-              <a:rPr lang="en-US" sz="1200" dirty="0">
-                <a:solidFill>
-                  <a:srgbClr val="059669"/>
-                </a:solidFill>
-              </a:rPr>
-              <a:t>✓</a:t>
-            </a:r>
-            <a:endParaRPr lang="en-US" sz="1200" dirty="0"/>
-          </a:p>
-        </p:txBody>
-      </p:sp>
-      <p:sp>
-        <p:nvSpPr>
-          <p:cNvPr id="27" name="Text 25"/>
-          <p:cNvSpPr/>
-          <p:nvPr/>
-        </p:nvSpPr>
-        <p:spPr>
-          <a:xfrm>
-            <a:off x="10332720" y="3154680"/>
-            <a:ext cx="1828800" cy="457200"/>
-          </a:xfrm>
-          <a:prstGeom prst="rect">
-            <a:avLst/>
-          </a:prstGeom>
-          <a:noFill/>
-          <a:ln/>
-        </p:spPr>
-        <p:txBody>
-          <a:bodyPr wrap="square" rtlCol="0" anchor="ctr"/>
-          <a:lstStyle/>
-          <a:p>
-            <a:pPr algn="ctr" indent="0" marL="0">
-              <a:buNone/>
-            </a:pPr>
-            <a:r>
-              <a:rPr lang="en-US" sz="1200" dirty="0">
-                <a:solidFill>
-                  <a:srgbClr val="059669"/>
-                </a:solidFill>
-              </a:rPr>
-              <a:t>✓</a:t>
-            </a:r>
-            <a:endParaRPr lang="en-US" sz="1200" dirty="0"/>
-          </a:p>
-        </p:txBody>
-      </p:sp>
-      <p:sp>
-        <p:nvSpPr>
-          <p:cNvPr id="28" name="Text 26"/>
-          <p:cNvSpPr/>
-          <p:nvPr/>
-        </p:nvSpPr>
-        <p:spPr>
-          <a:xfrm>
-            <a:off x="548640" y="3611880"/>
-            <a:ext cx="5943600" cy="457200"/>
-          </a:xfrm>
-          <a:prstGeom prst="rect">
-            <a:avLst/>
-          </a:prstGeom>
-          <a:noFill/>
-          <a:ln/>
-        </p:spPr>
-        <p:txBody>
-          <a:bodyPr wrap="square" rtlCol="0" anchor="ctr"/>
-          <a:lstStyle/>
-          <a:p>
-            <a:pPr algn="l" indent="0" marL="0">
-              <a:buNone/>
-            </a:pPr>
-            <a:r>
-              <a:rPr lang="en-US" sz="1200" b="1" dirty="0">
-                <a:solidFill>
-                  <a:srgbClr val="1E1B4B"/>
-                </a:solidFill>
-              </a:rPr>
-              <a:t>Tutor IA del curso</a:t>
-            </a:r>
-            <a:endParaRPr lang="en-US" sz="1200" dirty="0"/>
-          </a:p>
-        </p:txBody>
-      </p:sp>
-      <p:sp>
-        <p:nvSpPr>
-          <p:cNvPr id="29" name="Text 27"/>
-          <p:cNvSpPr/>
-          <p:nvPr/>
-        </p:nvSpPr>
-        <p:spPr>
-          <a:xfrm>
-            <a:off x="6583680" y="3611880"/>
-            <a:ext cx="1828800" cy="457200"/>
-          </a:xfrm>
-          <a:prstGeom prst="rect">
-            <a:avLst/>
-          </a:prstGeom>
-          <a:noFill/>
-          <a:ln/>
-        </p:spPr>
-        <p:txBody>
-          <a:bodyPr wrap="square" rtlCol="0" anchor="ctr"/>
-          <a:lstStyle/>
-          <a:p>
-            <a:pPr algn="ctr" indent="0" marL="0">
-              <a:buNone/>
-            </a:pPr>
-            <a:r>
-              <a:rPr lang="en-US" sz="1200" dirty="0">
-                <a:solidFill>
-                  <a:srgbClr val="94A3B8"/>
-                </a:solidFill>
-              </a:rPr>
-              <a:t>—</a:t>
-            </a:r>
-            <a:endParaRPr lang="en-US" sz="1200" dirty="0"/>
-          </a:p>
-        </p:txBody>
-      </p:sp>
-      <p:sp>
-        <p:nvSpPr>
-          <p:cNvPr id="30" name="Text 28"/>
-          <p:cNvSpPr/>
-          <p:nvPr/>
-        </p:nvSpPr>
-        <p:spPr>
-          <a:xfrm>
-            <a:off x="8458200" y="3611880"/>
-            <a:ext cx="1828800" cy="457200"/>
-          </a:xfrm>
-          <a:prstGeom prst="rect">
-            <a:avLst/>
-          </a:prstGeom>
-          <a:noFill/>
-          <a:ln/>
-        </p:spPr>
-        <p:txBody>
-          <a:bodyPr wrap="square" rtlCol="0" anchor="ctr"/>
-          <a:lstStyle/>
-          <a:p>
-            <a:pPr algn="ctr" indent="0" marL="0">
-              <a:buNone/>
-            </a:pPr>
-            <a:r>
-              <a:rPr lang="en-US" sz="1200" dirty="0">
-                <a:solidFill>
-                  <a:srgbClr val="059669"/>
-                </a:solidFill>
-              </a:rPr>
-              <a:t>✓</a:t>
-            </a:r>
-            <a:endParaRPr lang="en-US" sz="1200" dirty="0"/>
-          </a:p>
-        </p:txBody>
-      </p:sp>
-      <p:sp>
-        <p:nvSpPr>
-          <p:cNvPr id="31" name="Text 29"/>
-          <p:cNvSpPr/>
-          <p:nvPr/>
-        </p:nvSpPr>
-        <p:spPr>
-          <a:xfrm>
-            <a:off x="10332720" y="3611880"/>
-            <a:ext cx="1828800" cy="457200"/>
-          </a:xfrm>
-          <a:prstGeom prst="rect">
-            <a:avLst/>
-          </a:prstGeom>
-          <a:noFill/>
-          <a:ln/>
-        </p:spPr>
-        <p:txBody>
-          <a:bodyPr wrap="square" rtlCol="0" anchor="ctr"/>
-          <a:lstStyle/>
-          <a:p>
-            <a:pPr algn="ctr" indent="0" marL="0">
-              <a:buNone/>
-            </a:pPr>
-            <a:r>
-              <a:rPr lang="en-US" sz="1200" dirty="0">
-                <a:solidFill>
-                  <a:srgbClr val="059669"/>
-                </a:solidFill>
-              </a:rPr>
-              <a:t>✓</a:t>
-            </a:r>
-            <a:endParaRPr lang="en-US" sz="1200" dirty="0"/>
-          </a:p>
-        </p:txBody>
-      </p:sp>
-      <p:sp>
-        <p:nvSpPr>
-          <p:cNvPr id="32" name="Shape 30"/>
-          <p:cNvSpPr/>
-          <p:nvPr/>
-        </p:nvSpPr>
-        <p:spPr>
-          <a:xfrm>
-            <a:off x="457200" y="4069080"/>
-            <a:ext cx="11338560" cy="457200"/>
-          </a:xfrm>
-          <a:prstGeom prst="rect">
-            <a:avLst/>
-          </a:prstGeom>
-          <a:solidFill>
-            <a:srgbClr val="F5F3FF"/>
-          </a:solidFill>
-          <a:ln/>
-        </p:spPr>
-      </p:sp>
-      <p:sp>
-        <p:nvSpPr>
-          <p:cNvPr id="33" name="Text 31"/>
-          <p:cNvSpPr/>
-          <p:nvPr/>
-        </p:nvSpPr>
-        <p:spPr>
-          <a:xfrm>
-            <a:off x="548640" y="4069080"/>
-            <a:ext cx="5943600" cy="457200"/>
-          </a:xfrm>
-          <a:prstGeom prst="rect">
-            <a:avLst/>
-          </a:prstGeom>
-          <a:noFill/>
-          <a:ln/>
-        </p:spPr>
-        <p:txBody>
-          <a:bodyPr wrap="square" rtlCol="0" anchor="ctr"/>
-          <a:lstStyle/>
-          <a:p>
-            <a:pPr algn="l" indent="0" marL="0">
-              <a:buNone/>
-            </a:pPr>
-            <a:r>
-              <a:rPr lang="en-US" sz="1200" b="1" dirty="0">
-                <a:solidFill>
-                  <a:srgbClr val="1E1B4B"/>
-                </a:solidFill>
-              </a:rPr>
-              <a:t>Antifraude (detección de copia)</a:t>
-            </a:r>
-            <a:endParaRPr lang="en-US" sz="1200" dirty="0"/>
-          </a:p>
-        </p:txBody>
-      </p:sp>
-      <p:sp>
-        <p:nvSpPr>
-          <p:cNvPr id="34" name="Text 32"/>
-          <p:cNvSpPr/>
-          <p:nvPr/>
-        </p:nvSpPr>
-        <p:spPr>
-          <a:xfrm>
-            <a:off x="6583680" y="4069080"/>
-            <a:ext cx="1828800" cy="457200"/>
-          </a:xfrm>
-          <a:prstGeom prst="rect">
-            <a:avLst/>
-          </a:prstGeom>
-          <a:noFill/>
-          <a:ln/>
-        </p:spPr>
-        <p:txBody>
-          <a:bodyPr wrap="square" rtlCol="0" anchor="ctr"/>
-          <a:lstStyle/>
-          <a:p>
-            <a:pPr algn="ctr" indent="0" marL="0">
-              <a:buNone/>
-            </a:pPr>
-            <a:r>
-              <a:rPr lang="en-US" sz="1200" dirty="0">
-                <a:solidFill>
-                  <a:srgbClr val="94A3B8"/>
-                </a:solidFill>
-              </a:rPr>
-              <a:t>—</a:t>
-            </a:r>
-            <a:endParaRPr lang="en-US" sz="1200" dirty="0"/>
-          </a:p>
-        </p:txBody>
-      </p:sp>
-      <p:sp>
-        <p:nvSpPr>
-          <p:cNvPr id="35" name="Text 33"/>
-          <p:cNvSpPr/>
-          <p:nvPr/>
-        </p:nvSpPr>
-        <p:spPr>
-          <a:xfrm>
-            <a:off x="8458200" y="4069080"/>
-            <a:ext cx="1828800" cy="457200"/>
-          </a:xfrm>
-          <a:prstGeom prst="rect">
-            <a:avLst/>
-          </a:prstGeom>
-          <a:noFill/>
-          <a:ln/>
-        </p:spPr>
-        <p:txBody>
-          <a:bodyPr wrap="square" rtlCol="0" anchor="ctr"/>
-          <a:lstStyle/>
-          <a:p>
-            <a:pPr algn="ctr" indent="0" marL="0">
-              <a:buNone/>
-            </a:pPr>
-            <a:r>
-              <a:rPr lang="en-US" sz="1200" dirty="0">
-                <a:solidFill>
-                  <a:srgbClr val="059669"/>
-                </a:solidFill>
-              </a:rPr>
-              <a:t>✓</a:t>
-            </a:r>
-            <a:endParaRPr lang="en-US" sz="1200" dirty="0"/>
-          </a:p>
-        </p:txBody>
-      </p:sp>
-      <p:sp>
-        <p:nvSpPr>
-          <p:cNvPr id="36" name="Text 34"/>
-          <p:cNvSpPr/>
-          <p:nvPr/>
-        </p:nvSpPr>
-        <p:spPr>
-          <a:xfrm>
-            <a:off x="10332720" y="4069080"/>
-            <a:ext cx="1828800" cy="457200"/>
-          </a:xfrm>
-          <a:prstGeom prst="rect">
-            <a:avLst/>
-          </a:prstGeom>
-          <a:noFill/>
-          <a:ln/>
-        </p:spPr>
-        <p:txBody>
-          <a:bodyPr wrap="square" rtlCol="0" anchor="ctr"/>
-          <a:lstStyle/>
-          <a:p>
-            <a:pPr algn="ctr" indent="0" marL="0">
-              <a:buNone/>
-            </a:pPr>
-            <a:r>
-              <a:rPr lang="en-US" sz="1200" dirty="0">
-                <a:solidFill>
-                  <a:srgbClr val="059669"/>
-                </a:solidFill>
-              </a:rPr>
-              <a:t>✓</a:t>
-            </a:r>
-            <a:endParaRPr lang="en-US" sz="1200" dirty="0"/>
-          </a:p>
-        </p:txBody>
-      </p:sp>
-      <p:sp>
-        <p:nvSpPr>
-          <p:cNvPr id="37" name="Text 35"/>
-          <p:cNvSpPr/>
-          <p:nvPr/>
-        </p:nvSpPr>
-        <p:spPr>
-          <a:xfrm>
-            <a:off x="548640" y="4526280"/>
-            <a:ext cx="5943600" cy="457200"/>
-          </a:xfrm>
-          <a:prstGeom prst="rect">
-            <a:avLst/>
-          </a:prstGeom>
-          <a:noFill/>
-          <a:ln/>
-        </p:spPr>
-        <p:txBody>
-          <a:bodyPr wrap="square" rtlCol="0" anchor="ctr"/>
-          <a:lstStyle/>
-          <a:p>
-            <a:pPr algn="l" indent="0" marL="0">
-              <a:buNone/>
-            </a:pPr>
-            <a:r>
-              <a:rPr lang="en-US" sz="1200" b="1" dirty="0">
-                <a:solidFill>
-                  <a:srgbClr val="1E1B4B"/>
-                </a:solidFill>
-              </a:rPr>
-              <a:t>Sincronización de calendario y reportes</a:t>
-            </a:r>
-            <a:endParaRPr lang="en-US" sz="1200" dirty="0"/>
-          </a:p>
-        </p:txBody>
-      </p:sp>
-      <p:sp>
-        <p:nvSpPr>
-          <p:cNvPr id="38" name="Text 36"/>
-          <p:cNvSpPr/>
-          <p:nvPr/>
-        </p:nvSpPr>
-        <p:spPr>
-          <a:xfrm>
-            <a:off x="6583680" y="4526280"/>
-            <a:ext cx="1828800" cy="457200"/>
-          </a:xfrm>
-          <a:prstGeom prst="rect">
-            <a:avLst/>
-          </a:prstGeom>
-          <a:noFill/>
-          <a:ln/>
-        </p:spPr>
-        <p:txBody>
-          <a:bodyPr wrap="square" rtlCol="0" anchor="ctr"/>
-          <a:lstStyle/>
-          <a:p>
-            <a:pPr algn="ctr" indent="0" marL="0">
-              <a:buNone/>
-            </a:pPr>
-            <a:r>
-              <a:rPr lang="en-US" sz="1200" dirty="0">
-                <a:solidFill>
-                  <a:srgbClr val="94A3B8"/>
-                </a:solidFill>
-              </a:rPr>
-              <a:t>—</a:t>
-            </a:r>
-            <a:endParaRPr lang="en-US" sz="1200" dirty="0"/>
-          </a:p>
-        </p:txBody>
-      </p:sp>
-      <p:sp>
-        <p:nvSpPr>
-          <p:cNvPr id="39" name="Text 37"/>
-          <p:cNvSpPr/>
-          <p:nvPr/>
-        </p:nvSpPr>
-        <p:spPr>
-          <a:xfrm>
-            <a:off x="8458200" y="4526280"/>
-            <a:ext cx="1828800" cy="457200"/>
-          </a:xfrm>
-          <a:prstGeom prst="rect">
-            <a:avLst/>
-          </a:prstGeom>
-          <a:noFill/>
-          <a:ln/>
-        </p:spPr>
-        <p:txBody>
-          <a:bodyPr wrap="square" rtlCol="0" anchor="ctr"/>
-          <a:lstStyle/>
-          <a:p>
-            <a:pPr algn="ctr" indent="0" marL="0">
-              <a:buNone/>
-            </a:pPr>
-            <a:r>
-              <a:rPr lang="en-US" sz="1200" dirty="0">
-                <a:solidFill>
-                  <a:srgbClr val="059669"/>
-                </a:solidFill>
-              </a:rPr>
-              <a:t>✓</a:t>
-            </a:r>
-            <a:endParaRPr lang="en-US" sz="1200" dirty="0"/>
-          </a:p>
-        </p:txBody>
-      </p:sp>
-      <p:sp>
-        <p:nvSpPr>
-          <p:cNvPr id="40" name="Text 38"/>
-          <p:cNvSpPr/>
-          <p:nvPr/>
-        </p:nvSpPr>
-        <p:spPr>
-          <a:xfrm>
-            <a:off x="10332720" y="4526280"/>
-            <a:ext cx="1828800" cy="457200"/>
-          </a:xfrm>
-          <a:prstGeom prst="rect">
-            <a:avLst/>
-          </a:prstGeom>
-          <a:noFill/>
-          <a:ln/>
-        </p:spPr>
-        <p:txBody>
-          <a:bodyPr wrap="square" rtlCol="0" anchor="ctr"/>
-          <a:lstStyle/>
-          <a:p>
-            <a:pPr algn="ctr" indent="0" marL="0">
-              <a:buNone/>
-            </a:pPr>
-            <a:r>
-              <a:rPr lang="en-US" sz="1200" dirty="0">
-                <a:solidFill>
-                  <a:srgbClr val="059669"/>
-                </a:solidFill>
-              </a:rPr>
-              <a:t>✓</a:t>
-            </a:r>
-            <a:endParaRPr lang="en-US" sz="1200" dirty="0"/>
-          </a:p>
-        </p:txBody>
-      </p:sp>
-      <p:sp>
-        <p:nvSpPr>
-          <p:cNvPr id="41" name="Shape 39"/>
-          <p:cNvSpPr/>
-          <p:nvPr/>
-        </p:nvSpPr>
-        <p:spPr>
-          <a:xfrm>
-            <a:off x="457200" y="4983480"/>
-            <a:ext cx="11338560" cy="457200"/>
-          </a:xfrm>
-          <a:prstGeom prst="rect">
-            <a:avLst/>
-          </a:prstGeom>
-          <a:solidFill>
-            <a:srgbClr val="F5F3FF"/>
-          </a:solidFill>
-          <a:ln/>
-        </p:spPr>
-      </p:sp>
-      <p:sp>
-        <p:nvSpPr>
           <p:cNvPr id="42" name="Text 40"/>
-          <p:cNvSpPr/>
-          <p:nvPr/>
-        </p:nvSpPr>
-        <p:spPr>
-          <a:xfrm>
-            <a:off x="548640" y="4983480"/>
-            <a:ext cx="5943600" cy="457200"/>
-          </a:xfrm>
-          <a:prstGeom prst="rect">
-            <a:avLst/>
-          </a:prstGeom>
-          <a:noFill/>
-          <a:ln/>
-        </p:spPr>
-        <p:txBody>
-          <a:bodyPr wrap="square" rtlCol="0" anchor="ctr"/>
-          <a:lstStyle/>
-          <a:p>
-            <a:pPr algn="l" indent="0" marL="0">
-              <a:buNone/>
-            </a:pPr>
-            <a:r>
-              <a:rPr lang="en-US" sz="1200" b="1" dirty="0">
-                <a:solidFill>
-                  <a:srgbClr val="1E1B4B"/>
-                </a:solidFill>
-              </a:rPr>
-              <a:t>Multi-sede, branding y auditoría avanzada</a:t>
-            </a:r>
-            <a:endParaRPr lang="en-US" sz="1200" dirty="0"/>
-          </a:p>
-        </p:txBody>
-      </p:sp>
-      <p:sp>
-        <p:nvSpPr>
-          <p:cNvPr id="43" name="Text 41"/>
-          <p:cNvSpPr/>
-          <p:nvPr/>
-        </p:nvSpPr>
-        <p:spPr>
-          <a:xfrm>
-            <a:off x="6583680" y="4983480"/>
-            <a:ext cx="1828800" cy="457200"/>
-          </a:xfrm>
-          <a:prstGeom prst="rect">
-            <a:avLst/>
-          </a:prstGeom>
-          <a:noFill/>
-          <a:ln/>
-        </p:spPr>
-        <p:txBody>
-          <a:bodyPr wrap="square" rtlCol="0" anchor="ctr"/>
-          <a:lstStyle/>
-          <a:p>
-            <a:pPr algn="ctr" indent="0" marL="0">
-              <a:buNone/>
-            </a:pPr>
-            <a:r>
-              <a:rPr lang="en-US" sz="1200" dirty="0">
-                <a:solidFill>
-                  <a:srgbClr val="94A3B8"/>
-                </a:solidFill>
-              </a:rPr>
-              <a:t>—</a:t>
-            </a:r>
-            <a:endParaRPr lang="en-US" sz="1200" dirty="0"/>
-          </a:p>
-        </p:txBody>
-      </p:sp>
-      <p:sp>
-        <p:nvSpPr>
-          <p:cNvPr id="44" name="Text 42"/>
-          <p:cNvSpPr/>
-          <p:nvPr/>
-        </p:nvSpPr>
-        <p:spPr>
-          <a:xfrm>
-            <a:off x="8458200" y="4983480"/>
-            <a:ext cx="1828800" cy="457200"/>
-          </a:xfrm>
-          <a:prstGeom prst="rect">
-            <a:avLst/>
-          </a:prstGeom>
-          <a:noFill/>
-          <a:ln/>
-        </p:spPr>
-        <p:txBody>
-          <a:bodyPr wrap="square" rtlCol="0" anchor="ctr"/>
-          <a:lstStyle/>
-          <a:p>
-            <a:pPr algn="ctr" indent="0" marL="0">
-              <a:buNone/>
-            </a:pPr>
-            <a:r>
-              <a:rPr lang="en-US" sz="1200" dirty="0">
-                <a:solidFill>
-                  <a:srgbClr val="94A3B8"/>
-                </a:solidFill>
-              </a:rPr>
-              <a:t>—</a:t>
-            </a:r>
-            <a:endParaRPr lang="en-US" sz="1200" dirty="0"/>
-          </a:p>
-        </p:txBody>
-      </p:sp>
-      <p:sp>
-        <p:nvSpPr>
-          <p:cNvPr id="45" name="Text 43"/>
-          <p:cNvSpPr/>
-          <p:nvPr/>
-        </p:nvSpPr>
-        <p:spPr>
-          <a:xfrm>
-            <a:off x="10332720" y="4983480"/>
-            <a:ext cx="1828800" cy="457200"/>
-          </a:xfrm>
-          <a:prstGeom prst="rect">
-            <a:avLst/>
-          </a:prstGeom>
-          <a:noFill/>
-          <a:ln/>
-        </p:spPr>
-        <p:txBody>
-          <a:bodyPr wrap="square" rtlCol="0" anchor="ctr"/>
-          <a:lstStyle/>
-          <a:p>
-            <a:pPr algn="ctr" indent="0" marL="0">
-              <a:buNone/>
-            </a:pPr>
-            <a:r>
-              <a:rPr lang="en-US" sz="1200" dirty="0">
-                <a:solidFill>
-                  <a:srgbClr val="059669"/>
-                </a:solidFill>
-              </a:rPr>
-              <a:t>✓</a:t>
-            </a:r>
-            <a:endParaRPr lang="en-US" sz="1200" dirty="0"/>
-          </a:p>
-        </p:txBody>
-      </p:sp>
-      <p:sp>
-        <p:nvSpPr>
-          <p:cNvPr id="46" name="Text 44"/>
-          <p:cNvSpPr/>
-          <p:nvPr/>
-        </p:nvSpPr>
-        <p:spPr>
-          <a:xfrm>
-            <a:off x="548640" y="5440680"/>
-            <a:ext cx="5943600" cy="457200"/>
-          </a:xfrm>
-          <a:prstGeom prst="rect">
-            <a:avLst/>
-          </a:prstGeom>
-          <a:noFill/>
-          <a:ln/>
-        </p:spPr>
-        <p:txBody>
-          <a:bodyPr wrap="square" rtlCol="0" anchor="ctr"/>
-          <a:lstStyle/>
-          <a:p>
-            <a:pPr algn="l" indent="0" marL="0">
-              <a:buNone/>
-            </a:pPr>
-            <a:r>
-              <a:rPr lang="en-US" sz="1200" b="1" dirty="0">
-                <a:solidFill>
-                  <a:srgbClr val="1E1B4B"/>
-                </a:solidFill>
-              </a:rPr>
-              <a:t>Soporte prioritario</a:t>
-            </a:r>
-            <a:endParaRPr lang="en-US" sz="1200" dirty="0"/>
-          </a:p>
-        </p:txBody>
-      </p:sp>
-      <p:sp>
-        <p:nvSpPr>
-          <p:cNvPr id="47" name="Text 45"/>
-          <p:cNvSpPr/>
-          <p:nvPr/>
-        </p:nvSpPr>
-        <p:spPr>
-          <a:xfrm>
-            <a:off x="6583680" y="5440680"/>
-            <a:ext cx="1828800" cy="457200"/>
-          </a:xfrm>
-          <a:prstGeom prst="rect">
-            <a:avLst/>
-          </a:prstGeom>
-          <a:noFill/>
-          <a:ln/>
-        </p:spPr>
-        <p:txBody>
-          <a:bodyPr wrap="square" rtlCol="0" anchor="ctr"/>
-          <a:lstStyle/>
-          <a:p>
-            <a:pPr algn="ctr" indent="0" marL="0">
-              <a:buNone/>
-            </a:pPr>
-            <a:r>
-              <a:rPr lang="en-US" sz="1200" dirty="0">
-                <a:solidFill>
-                  <a:srgbClr val="1E1B4B"/>
-                </a:solidFill>
-              </a:rPr>
-              <a:t>Email</a:t>
-            </a:r>
-            <a:endParaRPr lang="en-US" sz="1200" dirty="0"/>
-          </a:p>
-        </p:txBody>
-      </p:sp>
-      <p:sp>
-        <p:nvSpPr>
-          <p:cNvPr id="48" name="Text 46"/>
-          <p:cNvSpPr/>
-          <p:nvPr/>
-        </p:nvSpPr>
-        <p:spPr>
-          <a:xfrm>
-            <a:off x="8458200" y="5440680"/>
-            <a:ext cx="1828800" cy="457200"/>
-          </a:xfrm>
-          <a:prstGeom prst="rect">
-            <a:avLst/>
-          </a:prstGeom>
-          <a:noFill/>
-          <a:ln/>
-        </p:spPr>
-        <p:txBody>
-          <a:bodyPr wrap="square" rtlCol="0" anchor="ctr"/>
-          <a:lstStyle/>
-          <a:p>
-            <a:pPr algn="ctr" indent="0" marL="0">
-              <a:buNone/>
-            </a:pPr>
-            <a:r>
-              <a:rPr lang="en-US" sz="1200" dirty="0">
-                <a:solidFill>
-                  <a:srgbClr val="1E1B4B"/>
-                </a:solidFill>
-              </a:rPr>
-              <a:t>Email</a:t>
-            </a:r>
-            <a:endParaRPr lang="en-US" sz="1200" dirty="0"/>
-          </a:p>
-        </p:txBody>
-      </p:sp>
-      <p:sp>
-        <p:nvSpPr>
-          <p:cNvPr id="49" name="Text 47"/>
-          <p:cNvSpPr/>
-          <p:nvPr/>
-        </p:nvSpPr>
-        <p:spPr>
-          <a:xfrm>
-            <a:off x="10332720" y="5440680"/>
-            <a:ext cx="1828800" cy="457200"/>
-          </a:xfrm>
-          <a:prstGeom prst="rect">
-            <a:avLst/>
-          </a:prstGeom>
-          <a:noFill/>
-          <a:ln/>
-        </p:spPr>
-        <p:txBody>
-          <a:bodyPr wrap="square" rtlCol="0" anchor="ctr"/>
-          <a:lstStyle/>
-          <a:p>
-            <a:pPr algn="ctr" indent="0" marL="0">
-              <a:buNone/>
-            </a:pPr>
-            <a:r>
-              <a:rPr lang="en-US" sz="1200" dirty="0">
-                <a:solidFill>
-                  <a:srgbClr val="1E1B4B"/>
-                </a:solidFill>
-              </a:rPr>
-              <a:t>Prioritario</a:t>
-            </a:r>
-            <a:endParaRPr lang="en-US" sz="1200" dirty="0"/>
-          </a:p>
-        </p:txBody>
-      </p:sp>
-      <p:sp>
-        <p:nvSpPr>
-          <p:cNvPr id="50" name="Shape 48"/>
-          <p:cNvSpPr/>
-          <p:nvPr/>
-        </p:nvSpPr>
-        <p:spPr>
-          <a:xfrm>
-            <a:off x="0" y="6565392"/>
-            <a:ext cx="12191695" cy="292608"/>
-          </a:xfrm>
-          <a:prstGeom prst="rect">
-            <a:avLst/>
-          </a:prstGeom>
-          <a:solidFill>
-            <a:srgbClr val="F5F3FF"/>
-          </a:solidFill>
-          <a:ln/>
-        </p:spPr>
-      </p:sp>
-      <p:sp>
-        <p:nvSpPr>
-          <p:cNvPr id="51" name="Text 49"/>
           <p:cNvSpPr/>
           <p:nvPr/>
         </p:nvSpPr>
@@ -5768,7 +5546,7 @@
       </p:sp>
       <p:sp>
         <p:nvSpPr>
-          <p:cNvPr id="52" name="Text 50"/>
+          <p:cNvPr id="43" name="Text 41"/>
           <p:cNvSpPr/>
           <p:nvPr/>
         </p:nvSpPr>

</xml_diff>

<commit_message>
chore(demos): regenera .pptx comercial con los planes nuevos ($1.000/5.000 + Contáctanos)
Co-Authored-By: Claude Opus 4.8 (1M context) <noreply@anthropic.com>
</commit_message>
<xml_diff>
--- a/docs/demos/presentacion/ExamLab-Presentacion-Comercial.pptx
+++ b/docs/demos/presentacion/ExamLab-Presentacion-Comercial.pptx
@@ -2473,7 +2473,7 @@
         <p:spPr>
           <a:xfrm>
             <a:off x="502920" y="1325880"/>
-            <a:ext cx="3611880" cy="4800600"/>
+            <a:ext cx="3611880" cy="4206240"/>
           </a:xfrm>
           <a:prstGeom prst="roundRect">
             <a:avLst>
@@ -2638,7 +2638,7 @@
         </p:nvSpPr>
         <p:spPr>
           <a:xfrm>
-            <a:off x="758952" y="3154680"/>
+            <a:off x="758952" y="3063240"/>
             <a:ext cx="1920240" cy="365760"/>
           </a:xfrm>
           <a:prstGeom prst="rect">
@@ -2674,7 +2674,7 @@
         </p:nvSpPr>
         <p:spPr>
           <a:xfrm>
-            <a:off x="2514600" y="3154680"/>
+            <a:off x="2514600" y="3063240"/>
             <a:ext cx="1371600" cy="365760"/>
           </a:xfrm>
           <a:prstGeom prst="rect">
@@ -2710,7 +2710,7 @@
         </p:nvSpPr>
         <p:spPr>
           <a:xfrm>
-            <a:off x="758952" y="3611880"/>
+            <a:off x="758952" y="3474720"/>
             <a:ext cx="1920240" cy="365760"/>
           </a:xfrm>
           <a:prstGeom prst="rect">
@@ -2746,7 +2746,7 @@
         </p:nvSpPr>
         <p:spPr>
           <a:xfrm>
-            <a:off x="2514600" y="3611880"/>
+            <a:off x="2514600" y="3474720"/>
             <a:ext cx="1371600" cy="365760"/>
           </a:xfrm>
           <a:prstGeom prst="rect">
@@ -2768,7 +2768,7 @@
                   <a:srgbClr val="1E1B4B"/>
                 </a:solidFill>
               </a:rPr>
-              <a:t>Hasta 20</a:t>
+              <a:t>Hasta 10</a:t>
             </a:r>
             <a:endParaRPr lang="en-US" sz="1300" dirty="0"/>
           </a:p>
@@ -2782,7 +2782,7 @@
         </p:nvSpPr>
         <p:spPr>
           <a:xfrm>
-            <a:off x="758952" y="4069080"/>
+            <a:off x="758952" y="3886200"/>
             <a:ext cx="1920240" cy="365760"/>
           </a:xfrm>
           <a:prstGeom prst="rect">
@@ -2818,7 +2818,7 @@
         </p:nvSpPr>
         <p:spPr>
           <a:xfrm>
-            <a:off x="2514600" y="4069080"/>
+            <a:off x="2514600" y="3886200"/>
             <a:ext cx="1371600" cy="365760"/>
           </a:xfrm>
           <a:prstGeom prst="rect">
@@ -2840,7 +2840,7 @@
                   <a:srgbClr val="1E1B4B"/>
                 </a:solidFill>
               </a:rPr>
-              <a:t>3</a:t>
+              <a:t>2</a:t>
             </a:r>
             <a:endParaRPr lang="en-US" sz="1300" dirty="0"/>
           </a:p>
@@ -2854,7 +2854,7 @@
         </p:nvSpPr>
         <p:spPr>
           <a:xfrm>
-            <a:off x="758952" y="4572000"/>
+            <a:off x="758952" y="4343400"/>
             <a:ext cx="3099816" cy="0"/>
           </a:xfrm>
           <a:prstGeom prst="line">
@@ -2877,8 +2877,8 @@
         </p:nvSpPr>
         <p:spPr>
           <a:xfrm>
-            <a:off x="777240" y="4709160"/>
-            <a:ext cx="3108960" cy="1280160"/>
+            <a:off x="777240" y="4453128"/>
+            <a:ext cx="3108960" cy="960120"/>
           </a:xfrm>
           <a:prstGeom prst="rect">
             <a:avLst/>
@@ -2892,7 +2892,7 @@
           <a:p>
             <a:pPr marL="342900" indent="-342900">
               <a:spcAft>
-                <a:spcPts val="600"/>
+                <a:spcPts val="500"/>
               </a:spcAft>
               <a:buSzPct val="100000"/>
               <a:buChar char="✓"/>
@@ -2910,7 +2910,7 @@
           <a:p>
             <a:pPr marL="342900" indent="-342900">
               <a:spcAft>
-                <a:spcPts val="600"/>
+                <a:spcPts val="500"/>
               </a:spcAft>
               <a:buSzPct val="100000"/>
               <a:buChar char="✓"/>
@@ -2928,7 +2928,7 @@
           <a:p>
             <a:pPr marL="342900" indent="-342900">
               <a:spcAft>
-                <a:spcPts val="600"/>
+                <a:spcPts val="500"/>
               </a:spcAft>
               <a:buSzPct val="100000"/>
               <a:buChar char="✓"/>
@@ -2954,7 +2954,7 @@
         <p:spPr>
           <a:xfrm>
             <a:off x="4251960" y="1161288"/>
-            <a:ext cx="3758184" cy="5129784"/>
+            <a:ext cx="3758184" cy="4535424"/>
           </a:xfrm>
           <a:prstGeom prst="roundRect">
             <a:avLst>
@@ -3166,7 +3166,7 @@
         </p:nvSpPr>
         <p:spPr>
           <a:xfrm>
-            <a:off x="4581144" y="3154680"/>
+            <a:off x="4581144" y="3063240"/>
             <a:ext cx="1920240" cy="365760"/>
           </a:xfrm>
           <a:prstGeom prst="rect">
@@ -3202,7 +3202,7 @@
         </p:nvSpPr>
         <p:spPr>
           <a:xfrm>
-            <a:off x="6336792" y="3154680"/>
+            <a:off x="6336792" y="3063240"/>
             <a:ext cx="1371600" cy="365760"/>
           </a:xfrm>
           <a:prstGeom prst="rect">
@@ -3238,7 +3238,7 @@
         </p:nvSpPr>
         <p:spPr>
           <a:xfrm>
-            <a:off x="4581144" y="3611880"/>
+            <a:off x="4581144" y="3474720"/>
             <a:ext cx="1920240" cy="365760"/>
           </a:xfrm>
           <a:prstGeom prst="rect">
@@ -3274,7 +3274,7 @@
         </p:nvSpPr>
         <p:spPr>
           <a:xfrm>
-            <a:off x="6336792" y="3611880"/>
+            <a:off x="6336792" y="3474720"/>
             <a:ext cx="1371600" cy="365760"/>
           </a:xfrm>
           <a:prstGeom prst="rect">
@@ -3296,7 +3296,7 @@
                   <a:srgbClr val="1E1B4B"/>
                 </a:solidFill>
               </a:rPr>
-              <a:t>Hasta 80</a:t>
+              <a:t>Hasta 40</a:t>
             </a:r>
             <a:endParaRPr lang="en-US" sz="1300" dirty="0"/>
           </a:p>
@@ -3310,7 +3310,7 @@
         </p:nvSpPr>
         <p:spPr>
           <a:xfrm>
-            <a:off x="4581144" y="4069080"/>
+            <a:off x="4581144" y="3886200"/>
             <a:ext cx="1920240" cy="365760"/>
           </a:xfrm>
           <a:prstGeom prst="rect">
@@ -3346,7 +3346,7 @@
         </p:nvSpPr>
         <p:spPr>
           <a:xfrm>
-            <a:off x="6336792" y="4069080"/>
+            <a:off x="6336792" y="3886200"/>
             <a:ext cx="1371600" cy="365760"/>
           </a:xfrm>
           <a:prstGeom prst="rect">
@@ -3368,7 +3368,7 @@
                   <a:srgbClr val="1E1B4B"/>
                 </a:solidFill>
               </a:rPr>
-              <a:t>6</a:t>
+              <a:t>4</a:t>
             </a:r>
             <a:endParaRPr lang="en-US" sz="1300" dirty="0"/>
           </a:p>
@@ -3382,7 +3382,7 @@
         </p:nvSpPr>
         <p:spPr>
           <a:xfrm>
-            <a:off x="4581144" y="4572000"/>
+            <a:off x="4581144" y="4343400"/>
             <a:ext cx="3099816" cy="0"/>
           </a:xfrm>
           <a:prstGeom prst="line">
@@ -3405,8 +3405,8 @@
         </p:nvSpPr>
         <p:spPr>
           <a:xfrm>
-            <a:off x="4599432" y="4709160"/>
-            <a:ext cx="3108960" cy="1280160"/>
+            <a:off x="4599432" y="4453128"/>
+            <a:ext cx="3108960" cy="960120"/>
           </a:xfrm>
           <a:prstGeom prst="rect">
             <a:avLst/>
@@ -3420,7 +3420,7 @@
           <a:p>
             <a:pPr marL="342900" indent="-342900">
               <a:spcAft>
-                <a:spcPts val="600"/>
+                <a:spcPts val="500"/>
               </a:spcAft>
               <a:buSzPct val="100000"/>
               <a:buChar char="✓"/>
@@ -3438,7 +3438,7 @@
           <a:p>
             <a:pPr marL="342900" indent="-342900">
               <a:spcAft>
-                <a:spcPts val="600"/>
+                <a:spcPts val="500"/>
               </a:spcAft>
               <a:buSzPct val="100000"/>
               <a:buChar char="✓"/>
@@ -3456,7 +3456,7 @@
           <a:p>
             <a:pPr marL="342900" indent="-342900">
               <a:spcAft>
-                <a:spcPts val="600"/>
+                <a:spcPts val="500"/>
               </a:spcAft>
               <a:buSzPct val="100000"/>
               <a:buChar char="✓"/>
@@ -3482,7 +3482,7 @@
         <p:spPr>
           <a:xfrm>
             <a:off x="8147304" y="1325880"/>
-            <a:ext cx="3611880" cy="4800600"/>
+            <a:ext cx="3611880" cy="4206240"/>
           </a:xfrm>
           <a:prstGeom prst="roundRect">
             <a:avLst>
@@ -3622,7 +3622,7 @@
                   <a:srgbClr val="4F46E5"/>
                 </a:solidFill>
               </a:rPr>
-              <a:t>$1.290</a:t>
+              <a:t>$1.000</a:t>
             </a:r>
             <a:pPr indent="0" marL="0">
               <a:buNone/>
@@ -3647,7 +3647,7 @@
         </p:nvSpPr>
         <p:spPr>
           <a:xfrm>
-            <a:off x="8403336" y="3154680"/>
+            <a:off x="8403336" y="3063240"/>
             <a:ext cx="1920240" cy="365760"/>
           </a:xfrm>
           <a:prstGeom prst="rect">
@@ -3683,7 +3683,7 @@
         </p:nvSpPr>
         <p:spPr>
           <a:xfrm>
-            <a:off x="10158984" y="3154680"/>
+            <a:off x="10158984" y="3063240"/>
             <a:ext cx="1371600" cy="365760"/>
           </a:xfrm>
           <a:prstGeom prst="rect">
@@ -3705,7 +3705,7 @@
                   <a:srgbClr val="1E1B4B"/>
                 </a:solidFill>
               </a:rPr>
-              <a:t>Hasta 6.000</a:t>
+              <a:t>Hasta 5.000</a:t>
             </a:r>
             <a:endParaRPr lang="en-US" sz="1300" dirty="0"/>
           </a:p>
@@ -3719,7 +3719,7 @@
         </p:nvSpPr>
         <p:spPr>
           <a:xfrm>
-            <a:off x="8403336" y="3611880"/>
+            <a:off x="8403336" y="3474720"/>
             <a:ext cx="1920240" cy="365760"/>
           </a:xfrm>
           <a:prstGeom prst="rect">
@@ -3755,7 +3755,7 @@
         </p:nvSpPr>
         <p:spPr>
           <a:xfrm>
-            <a:off x="10158984" y="3611880"/>
+            <a:off x="10158984" y="3474720"/>
             <a:ext cx="1371600" cy="365760"/>
           </a:xfrm>
           <a:prstGeom prst="rect">
@@ -3777,7 +3777,7 @@
                   <a:srgbClr val="1E1B4B"/>
                 </a:solidFill>
               </a:rPr>
-              <a:t>Hasta 300</a:t>
+              <a:t>Hasta 150</a:t>
             </a:r>
             <a:endParaRPr lang="en-US" sz="1300" dirty="0"/>
           </a:p>
@@ -3791,7 +3791,7 @@
         </p:nvSpPr>
         <p:spPr>
           <a:xfrm>
-            <a:off x="8403336" y="4069080"/>
+            <a:off x="8403336" y="3886200"/>
             <a:ext cx="1920240" cy="365760"/>
           </a:xfrm>
           <a:prstGeom prst="rect">
@@ -3827,7 +3827,7 @@
         </p:nvSpPr>
         <p:spPr>
           <a:xfrm>
-            <a:off x="10158984" y="4069080"/>
+            <a:off x="10158984" y="3886200"/>
             <a:ext cx="1371600" cy="365760"/>
           </a:xfrm>
           <a:prstGeom prst="rect">
@@ -3849,7 +3849,7 @@
                   <a:srgbClr val="1E1B4B"/>
                 </a:solidFill>
               </a:rPr>
-              <a:t>12</a:t>
+              <a:t>8</a:t>
             </a:r>
             <a:endParaRPr lang="en-US" sz="1300" dirty="0"/>
           </a:p>
@@ -3863,7 +3863,7 @@
         </p:nvSpPr>
         <p:spPr>
           <a:xfrm>
-            <a:off x="8403336" y="4572000"/>
+            <a:off x="8403336" y="4343400"/>
             <a:ext cx="3099816" cy="0"/>
           </a:xfrm>
           <a:prstGeom prst="line">
@@ -3886,8 +3886,8 @@
         </p:nvSpPr>
         <p:spPr>
           <a:xfrm>
-            <a:off x="8421624" y="4709160"/>
-            <a:ext cx="3108960" cy="1280160"/>
+            <a:off x="8421624" y="4453128"/>
+            <a:ext cx="3108960" cy="960120"/>
           </a:xfrm>
           <a:prstGeom prst="rect">
             <a:avLst/>
@@ -3901,7 +3901,7 @@
           <a:p>
             <a:pPr marL="342900" indent="-342900">
               <a:spcAft>
-                <a:spcPts val="600"/>
+                <a:spcPts val="500"/>
               </a:spcAft>
               <a:buSzPct val="100000"/>
               <a:buChar char="✓"/>
@@ -3919,7 +3919,7 @@
           <a:p>
             <a:pPr marL="342900" indent="-342900">
               <a:spcAft>
-                <a:spcPts val="600"/>
+                <a:spcPts val="500"/>
               </a:spcAft>
               <a:buSzPct val="100000"/>
               <a:buChar char="✓"/>
@@ -3937,7 +3937,7 @@
           <a:p>
             <a:pPr marL="342900" indent="-342900">
               <a:spcAft>
-                <a:spcPts val="600"/>
+                <a:spcPts val="500"/>
               </a:spcAft>
               <a:buSzPct val="100000"/>
               <a:buChar char="✓"/>
@@ -3956,19 +3956,92 @@
       </p:sp>
       <p:sp>
         <p:nvSpPr>
-          <p:cNvPr id="46" name="Text 44"/>
-          <p:cNvSpPr/>
-          <p:nvPr/>
-        </p:nvSpPr>
-        <p:spPr>
-          <a:xfrm>
-            <a:off x="502920" y="6254496"/>
-            <a:ext cx="11155680" cy="310896"/>
-          </a:xfrm>
-          <a:prstGeom prst="rect">
-            <a:avLst/>
-          </a:prstGeom>
-          <a:noFill/>
+          <p:cNvPr id="46" name="Shape 44"/>
+          <p:cNvSpPr/>
+          <p:nvPr/>
+        </p:nvSpPr>
+        <p:spPr>
+          <a:xfrm>
+            <a:off x="502920" y="5623560"/>
+            <a:ext cx="11183112" cy="530352"/>
+          </a:xfrm>
+          <a:prstGeom prst="roundRect">
+            <a:avLst>
+              <a:gd name="adj" fmla="val 17241"/>
+            </a:avLst>
+          </a:prstGeom>
+          <a:solidFill>
+            <a:srgbClr val="1E1B4B"/>
+          </a:solidFill>
+          <a:ln/>
+        </p:spPr>
+      </p:sp>
+      <p:sp>
+        <p:nvSpPr>
+          <p:cNvPr id="47" name="Text 45"/>
+          <p:cNvSpPr/>
+          <p:nvPr/>
+        </p:nvSpPr>
+        <p:spPr>
+          <a:xfrm>
+            <a:off x="868680" y="5623560"/>
+            <a:ext cx="7863840" cy="530352"/>
+          </a:xfrm>
+          <a:prstGeom prst="rect">
+            <a:avLst/>
+          </a:prstGeom>
+          <a:noFill/>
+          <a:ln/>
+        </p:spPr>
+        <p:txBody>
+          <a:bodyPr wrap="square" rtlCol="0" anchor="ctr"/>
+          <a:lstStyle/>
+          <a:p>
+            <a:pPr indent="0" marL="0">
+              <a:buNone/>
+            </a:pPr>
+            <a:r>
+              <a:rPr lang="en-US" sz="1400" b="1" dirty="0">
+                <a:solidFill>
+                  <a:srgbClr val="FFFFFF"/>
+                </a:solidFill>
+              </a:rPr>
+              <a:t>¿Más de 5.000 estudiantes?  </a:t>
+            </a:r>
+            <a:pPr indent="0" marL="0">
+              <a:buNone/>
+            </a:pPr>
+            <a:r>
+              <a:rPr lang="en-US" sz="1250" dirty="0">
+                <a:solidFill>
+                  <a:srgbClr val="E0E7FF"/>
+                </a:solidFill>
+              </a:rPr>
+              <a:t>Diseñamos un plan a la medida para tu institución.</a:t>
+            </a:r>
+            <a:endParaRPr lang="en-US" sz="1400" dirty="0"/>
+          </a:p>
+        </p:txBody>
+      </p:sp>
+      <p:sp>
+        <p:nvSpPr>
+          <p:cNvPr id="48" name="Text 46"/>
+          <p:cNvSpPr/>
+          <p:nvPr/>
+        </p:nvSpPr>
+        <p:spPr>
+          <a:xfrm>
+            <a:off x="8869680" y="5705856"/>
+            <a:ext cx="2651760" cy="365760"/>
+          </a:xfrm>
+          <a:prstGeom prst="roundRect">
+            <a:avLst>
+              <a:gd name="adj" fmla="val 20000"/>
+            </a:avLst>
+          </a:prstGeom>
+          <a:solidFill>
+            <a:srgbClr val="FACC15"/>
+          </a:solidFill>
           <a:ln/>
         </p:spPr>
         <p:txBody>
@@ -3979,20 +4052,56 @@
               <a:buNone/>
             </a:pPr>
             <a:r>
-              <a:rPr lang="en-US" sz="950" i="1" dirty="0">
+              <a:rPr lang="en-US" sz="1300" b="1" dirty="0">
+                <a:solidFill>
+                  <a:srgbClr val="1E1B4B"/>
+                </a:solidFill>
+              </a:rPr>
+              <a:t>Contáctanos →</a:t>
+            </a:r>
+            <a:endParaRPr lang="en-US" sz="1300" dirty="0"/>
+          </a:p>
+        </p:txBody>
+      </p:sp>
+      <p:sp>
+        <p:nvSpPr>
+          <p:cNvPr id="49" name="Text 47"/>
+          <p:cNvSpPr/>
+          <p:nvPr/>
+        </p:nvSpPr>
+        <p:spPr>
+          <a:xfrm>
+            <a:off x="502920" y="6217920"/>
+            <a:ext cx="11155680" cy="292608"/>
+          </a:xfrm>
+          <a:prstGeom prst="rect">
+            <a:avLst/>
+          </a:prstGeom>
+          <a:noFill/>
+          <a:ln/>
+        </p:spPr>
+        <p:txBody>
+          <a:bodyPr wrap="square" rtlCol="0" anchor="ctr"/>
+          <a:lstStyle/>
+          <a:p>
+            <a:pPr algn="ctr" indent="0" marL="0">
+              <a:buNone/>
+            </a:pPr>
+            <a:r>
+              <a:rPr lang="en-US" sz="900" i="1" dirty="0">
                 <a:solidFill>
                   <a:srgbClr val="64748B"/>
                 </a:solidFill>
               </a:rPr>
-              <a:t>Precios de referencia (USD/mes) — incluyen plataforma, infraestructura y soporte. El API key de IA lo provee la institución (su uso de IA no se factura en la suscripción). Ajustar a la política comercial.</a:t>
-            </a:r>
-            <a:endParaRPr lang="en-US" sz="950" dirty="0"/>
-          </a:p>
-        </p:txBody>
-      </p:sp>
-      <p:sp>
-        <p:nvSpPr>
-          <p:cNvPr id="47" name="Shape 45"/>
+              <a:t>Precios de referencia (USD/mes) — incluyen plataforma, infraestructura y soporte. El API key de IA lo provee la institución (su uso de IA no se factura en la suscripción). Más de 5.000 estudiantes: plan a la medida con el equipo de ventas. Ajustar a la política comercial.</a:t>
+            </a:r>
+            <a:endParaRPr lang="en-US" sz="900" dirty="0"/>
+          </a:p>
+        </p:txBody>
+      </p:sp>
+      <p:sp>
+        <p:nvSpPr>
+          <p:cNvPr id="50" name="Shape 48"/>
           <p:cNvSpPr/>
           <p:nvPr/>
         </p:nvSpPr>
@@ -4012,7 +4121,7 @@
       </p:sp>
       <p:sp>
         <p:nvSpPr>
-          <p:cNvPr id="48" name="Text 46"/>
+          <p:cNvPr id="51" name="Text 49"/>
           <p:cNvSpPr/>
           <p:nvPr/>
         </p:nvSpPr>
@@ -4048,7 +4157,7 @@
       </p:sp>
       <p:sp>
         <p:nvSpPr>
-          <p:cNvPr id="49" name="Text 47"/>
+          <p:cNvPr id="52" name="Text 50"/>
           <p:cNvSpPr/>
           <p:nvPr/>
         </p:nvSpPr>

</xml_diff>

<commit_message>
fix(demos): planes comerciales — badge "MÁS POPULAR" sin solapar + menos docentes
- Badge ya no se monta sobre el subtítulo del encabezado (fila de tarjetas
  bajada y badge con menor protrusión; 0.37" de holgura verificada).
- Recomprimido el cuerpo de las tarjetas para que todo quepa sobre el footer
  sin solapamientos (features, banner Contáctanos y nota al pie).
- Docentes reducidos: Esencial 5, Profesional 20, Institucional 100
  (antes 10 / 40 / 150). Administradores siguen en 2 / 4 / 8.

Co-Authored-By: Claude Opus 4.8 (1M context) <noreply@anthropic.com>
</commit_message>
<xml_diff>
--- a/docs/demos/presentacion/ExamLab-Presentacion-Comercial.pptx
+++ b/docs/demos/presentacion/ExamLab-Presentacion-Comercial.pptx
@@ -2472,8 +2472,8 @@
         </p:nvSpPr>
         <p:spPr>
           <a:xfrm>
-            <a:off x="502920" y="1325880"/>
-            <a:ext cx="3611880" cy="4206240"/>
+            <a:off x="502920" y="1691640"/>
+            <a:ext cx="3611880" cy="3794760"/>
           </a:xfrm>
           <a:prstGeom prst="roundRect">
             <a:avLst>
@@ -2499,7 +2499,7 @@
         </p:nvSpPr>
         <p:spPr>
           <a:xfrm>
-            <a:off x="502920" y="1325880"/>
+            <a:off x="502920" y="1691640"/>
             <a:ext cx="3611880" cy="109728"/>
           </a:xfrm>
           <a:prstGeom prst="rect">
@@ -2519,7 +2519,7 @@
         </p:nvSpPr>
         <p:spPr>
           <a:xfrm>
-            <a:off x="731520" y="1581912"/>
+            <a:off x="731520" y="1947672"/>
             <a:ext cx="3154680" cy="457200"/>
           </a:xfrm>
           <a:prstGeom prst="rect">
@@ -2555,7 +2555,7 @@
         </p:nvSpPr>
         <p:spPr>
           <a:xfrm>
-            <a:off x="731520" y="2075688"/>
+            <a:off x="731520" y="2441448"/>
             <a:ext cx="3154680" cy="320040"/>
           </a:xfrm>
           <a:prstGeom prst="rect">
@@ -2591,8 +2591,8 @@
         </p:nvSpPr>
         <p:spPr>
           <a:xfrm>
-            <a:off x="731520" y="2423160"/>
-            <a:ext cx="3154680" cy="548640"/>
+            <a:off x="731520" y="2788920"/>
+            <a:ext cx="3154680" cy="457200"/>
           </a:xfrm>
           <a:prstGeom prst="rect">
             <a:avLst/>
@@ -2638,7 +2638,7 @@
         </p:nvSpPr>
         <p:spPr>
           <a:xfrm>
-            <a:off x="758952" y="3063240"/>
+            <a:off x="758952" y="3291840"/>
             <a:ext cx="1920240" cy="365760"/>
           </a:xfrm>
           <a:prstGeom prst="rect">
@@ -2674,7 +2674,7 @@
         </p:nvSpPr>
         <p:spPr>
           <a:xfrm>
-            <a:off x="2514600" y="3063240"/>
+            <a:off x="2514600" y="3291840"/>
             <a:ext cx="1371600" cy="365760"/>
           </a:xfrm>
           <a:prstGeom prst="rect">
@@ -2710,7 +2710,7 @@
         </p:nvSpPr>
         <p:spPr>
           <a:xfrm>
-            <a:off x="758952" y="3474720"/>
+            <a:off x="758952" y="3657600"/>
             <a:ext cx="1920240" cy="365760"/>
           </a:xfrm>
           <a:prstGeom prst="rect">
@@ -2746,7 +2746,7 @@
         </p:nvSpPr>
         <p:spPr>
           <a:xfrm>
-            <a:off x="2514600" y="3474720"/>
+            <a:off x="2514600" y="3657600"/>
             <a:ext cx="1371600" cy="365760"/>
           </a:xfrm>
           <a:prstGeom prst="rect">
@@ -2768,7 +2768,7 @@
                   <a:srgbClr val="1E1B4B"/>
                 </a:solidFill>
               </a:rPr>
-              <a:t>Hasta 10</a:t>
+              <a:t>Hasta 5</a:t>
             </a:r>
             <a:endParaRPr lang="en-US" sz="1300" dirty="0"/>
           </a:p>
@@ -2782,7 +2782,7 @@
         </p:nvSpPr>
         <p:spPr>
           <a:xfrm>
-            <a:off x="758952" y="3886200"/>
+            <a:off x="758952" y="4023360"/>
             <a:ext cx="1920240" cy="365760"/>
           </a:xfrm>
           <a:prstGeom prst="rect">
@@ -2818,7 +2818,7 @@
         </p:nvSpPr>
         <p:spPr>
           <a:xfrm>
-            <a:off x="2514600" y="3886200"/>
+            <a:off x="2514600" y="4023360"/>
             <a:ext cx="1371600" cy="365760"/>
           </a:xfrm>
           <a:prstGeom prst="rect">
@@ -2854,7 +2854,7 @@
         </p:nvSpPr>
         <p:spPr>
           <a:xfrm>
-            <a:off x="758952" y="4343400"/>
+            <a:off x="758952" y="4434840"/>
             <a:ext cx="3099816" cy="0"/>
           </a:xfrm>
           <a:prstGeom prst="line">
@@ -2877,8 +2877,8 @@
         </p:nvSpPr>
         <p:spPr>
           <a:xfrm>
-            <a:off x="777240" y="4453128"/>
-            <a:ext cx="3108960" cy="960120"/>
+            <a:off x="777240" y="4544568"/>
+            <a:ext cx="3108960" cy="841248"/>
           </a:xfrm>
           <a:prstGeom prst="rect">
             <a:avLst/>
@@ -2953,8 +2953,8 @@
         </p:nvSpPr>
         <p:spPr>
           <a:xfrm>
-            <a:off x="4251960" y="1161288"/>
-            <a:ext cx="3758184" cy="4535424"/>
+            <a:off x="4251960" y="1527048"/>
+            <a:ext cx="3758184" cy="4123944"/>
           </a:xfrm>
           <a:prstGeom prst="roundRect">
             <a:avLst>
@@ -2987,12 +2987,12 @@
         </p:nvSpPr>
         <p:spPr>
           <a:xfrm>
-            <a:off x="5216652" y="886968"/>
-            <a:ext cx="1828800" cy="329184"/>
+            <a:off x="5216652" y="1399032"/>
+            <a:ext cx="1828800" cy="310896"/>
           </a:xfrm>
           <a:prstGeom prst="roundRect">
             <a:avLst>
-              <a:gd name="adj" fmla="val 22222"/>
+              <a:gd name="adj" fmla="val 23529"/>
             </a:avLst>
           </a:prstGeom>
           <a:solidFill>
@@ -3027,7 +3027,7 @@
         </p:nvSpPr>
         <p:spPr>
           <a:xfrm>
-            <a:off x="4325112" y="1325880"/>
+            <a:off x="4325112" y="1691640"/>
             <a:ext cx="3611880" cy="109728"/>
           </a:xfrm>
           <a:prstGeom prst="rect">
@@ -3047,7 +3047,7 @@
         </p:nvSpPr>
         <p:spPr>
           <a:xfrm>
-            <a:off x="4553712" y="1581912"/>
+            <a:off x="4553712" y="1947672"/>
             <a:ext cx="3154680" cy="457200"/>
           </a:xfrm>
           <a:prstGeom prst="rect">
@@ -3083,7 +3083,7 @@
         </p:nvSpPr>
         <p:spPr>
           <a:xfrm>
-            <a:off x="4553712" y="2075688"/>
+            <a:off x="4553712" y="2441448"/>
             <a:ext cx="3154680" cy="320040"/>
           </a:xfrm>
           <a:prstGeom prst="rect">
@@ -3119,8 +3119,8 @@
         </p:nvSpPr>
         <p:spPr>
           <a:xfrm>
-            <a:off x="4553712" y="2423160"/>
-            <a:ext cx="3154680" cy="548640"/>
+            <a:off x="4553712" y="2788920"/>
+            <a:ext cx="3154680" cy="457200"/>
           </a:xfrm>
           <a:prstGeom prst="rect">
             <a:avLst/>
@@ -3166,7 +3166,7 @@
         </p:nvSpPr>
         <p:spPr>
           <a:xfrm>
-            <a:off x="4581144" y="3063240"/>
+            <a:off x="4581144" y="3291840"/>
             <a:ext cx="1920240" cy="365760"/>
           </a:xfrm>
           <a:prstGeom prst="rect">
@@ -3202,7 +3202,7 @@
         </p:nvSpPr>
         <p:spPr>
           <a:xfrm>
-            <a:off x="6336792" y="3063240"/>
+            <a:off x="6336792" y="3291840"/>
             <a:ext cx="1371600" cy="365760"/>
           </a:xfrm>
           <a:prstGeom prst="rect">
@@ -3238,7 +3238,7 @@
         </p:nvSpPr>
         <p:spPr>
           <a:xfrm>
-            <a:off x="4581144" y="3474720"/>
+            <a:off x="4581144" y="3657600"/>
             <a:ext cx="1920240" cy="365760"/>
           </a:xfrm>
           <a:prstGeom prst="rect">
@@ -3274,7 +3274,7 @@
         </p:nvSpPr>
         <p:spPr>
           <a:xfrm>
-            <a:off x="6336792" y="3474720"/>
+            <a:off x="6336792" y="3657600"/>
             <a:ext cx="1371600" cy="365760"/>
           </a:xfrm>
           <a:prstGeom prst="rect">
@@ -3296,7 +3296,7 @@
                   <a:srgbClr val="1E1B4B"/>
                 </a:solidFill>
               </a:rPr>
-              <a:t>Hasta 40</a:t>
+              <a:t>Hasta 20</a:t>
             </a:r>
             <a:endParaRPr lang="en-US" sz="1300" dirty="0"/>
           </a:p>
@@ -3310,7 +3310,7 @@
         </p:nvSpPr>
         <p:spPr>
           <a:xfrm>
-            <a:off x="4581144" y="3886200"/>
+            <a:off x="4581144" y="4023360"/>
             <a:ext cx="1920240" cy="365760"/>
           </a:xfrm>
           <a:prstGeom prst="rect">
@@ -3346,7 +3346,7 @@
         </p:nvSpPr>
         <p:spPr>
           <a:xfrm>
-            <a:off x="6336792" y="3886200"/>
+            <a:off x="6336792" y="4023360"/>
             <a:ext cx="1371600" cy="365760"/>
           </a:xfrm>
           <a:prstGeom prst="rect">
@@ -3382,7 +3382,7 @@
         </p:nvSpPr>
         <p:spPr>
           <a:xfrm>
-            <a:off x="4581144" y="4343400"/>
+            <a:off x="4581144" y="4434840"/>
             <a:ext cx="3099816" cy="0"/>
           </a:xfrm>
           <a:prstGeom prst="line">
@@ -3405,8 +3405,8 @@
         </p:nvSpPr>
         <p:spPr>
           <a:xfrm>
-            <a:off x="4599432" y="4453128"/>
-            <a:ext cx="3108960" cy="960120"/>
+            <a:off x="4599432" y="4544568"/>
+            <a:ext cx="3108960" cy="841248"/>
           </a:xfrm>
           <a:prstGeom prst="rect">
             <a:avLst/>
@@ -3481,8 +3481,8 @@
         </p:nvSpPr>
         <p:spPr>
           <a:xfrm>
-            <a:off x="8147304" y="1325880"/>
-            <a:ext cx="3611880" cy="4206240"/>
+            <a:off x="8147304" y="1691640"/>
+            <a:ext cx="3611880" cy="3794760"/>
           </a:xfrm>
           <a:prstGeom prst="roundRect">
             <a:avLst>
@@ -3508,7 +3508,7 @@
         </p:nvSpPr>
         <p:spPr>
           <a:xfrm>
-            <a:off x="8147304" y="1325880"/>
+            <a:off x="8147304" y="1691640"/>
             <a:ext cx="3611880" cy="109728"/>
           </a:xfrm>
           <a:prstGeom prst="rect">
@@ -3528,7 +3528,7 @@
         </p:nvSpPr>
         <p:spPr>
           <a:xfrm>
-            <a:off x="8375904" y="1581912"/>
+            <a:off x="8375904" y="1947672"/>
             <a:ext cx="3154680" cy="457200"/>
           </a:xfrm>
           <a:prstGeom prst="rect">
@@ -3564,7 +3564,7 @@
         </p:nvSpPr>
         <p:spPr>
           <a:xfrm>
-            <a:off x="8375904" y="2075688"/>
+            <a:off x="8375904" y="2441448"/>
             <a:ext cx="3154680" cy="320040"/>
           </a:xfrm>
           <a:prstGeom prst="rect">
@@ -3600,8 +3600,8 @@
         </p:nvSpPr>
         <p:spPr>
           <a:xfrm>
-            <a:off x="8375904" y="2423160"/>
-            <a:ext cx="3154680" cy="548640"/>
+            <a:off x="8375904" y="2788920"/>
+            <a:ext cx="3154680" cy="457200"/>
           </a:xfrm>
           <a:prstGeom prst="rect">
             <a:avLst/>
@@ -3647,7 +3647,7 @@
         </p:nvSpPr>
         <p:spPr>
           <a:xfrm>
-            <a:off x="8403336" y="3063240"/>
+            <a:off x="8403336" y="3291840"/>
             <a:ext cx="1920240" cy="365760"/>
           </a:xfrm>
           <a:prstGeom prst="rect">
@@ -3683,7 +3683,7 @@
         </p:nvSpPr>
         <p:spPr>
           <a:xfrm>
-            <a:off x="10158984" y="3063240"/>
+            <a:off x="10158984" y="3291840"/>
             <a:ext cx="1371600" cy="365760"/>
           </a:xfrm>
           <a:prstGeom prst="rect">
@@ -3719,7 +3719,7 @@
         </p:nvSpPr>
         <p:spPr>
           <a:xfrm>
-            <a:off x="8403336" y="3474720"/>
+            <a:off x="8403336" y="3657600"/>
             <a:ext cx="1920240" cy="365760"/>
           </a:xfrm>
           <a:prstGeom prst="rect">
@@ -3755,7 +3755,7 @@
         </p:nvSpPr>
         <p:spPr>
           <a:xfrm>
-            <a:off x="10158984" y="3474720"/>
+            <a:off x="10158984" y="3657600"/>
             <a:ext cx="1371600" cy="365760"/>
           </a:xfrm>
           <a:prstGeom prst="rect">
@@ -3777,7 +3777,7 @@
                   <a:srgbClr val="1E1B4B"/>
                 </a:solidFill>
               </a:rPr>
-              <a:t>Hasta 150</a:t>
+              <a:t>Hasta 100</a:t>
             </a:r>
             <a:endParaRPr lang="en-US" sz="1300" dirty="0"/>
           </a:p>
@@ -3791,7 +3791,7 @@
         </p:nvSpPr>
         <p:spPr>
           <a:xfrm>
-            <a:off x="8403336" y="3886200"/>
+            <a:off x="8403336" y="4023360"/>
             <a:ext cx="1920240" cy="365760"/>
           </a:xfrm>
           <a:prstGeom prst="rect">
@@ -3827,7 +3827,7 @@
         </p:nvSpPr>
         <p:spPr>
           <a:xfrm>
-            <a:off x="10158984" y="3886200"/>
+            <a:off x="10158984" y="4023360"/>
             <a:ext cx="1371600" cy="365760"/>
           </a:xfrm>
           <a:prstGeom prst="rect">
@@ -3863,7 +3863,7 @@
         </p:nvSpPr>
         <p:spPr>
           <a:xfrm>
-            <a:off x="8403336" y="4343400"/>
+            <a:off x="8403336" y="4434840"/>
             <a:ext cx="3099816" cy="0"/>
           </a:xfrm>
           <a:prstGeom prst="line">
@@ -3886,8 +3886,8 @@
         </p:nvSpPr>
         <p:spPr>
           <a:xfrm>
-            <a:off x="8421624" y="4453128"/>
-            <a:ext cx="3108960" cy="960120"/>
+            <a:off x="8421624" y="4544568"/>
+            <a:ext cx="3108960" cy="841248"/>
           </a:xfrm>
           <a:prstGeom prst="rect">
             <a:avLst/>
@@ -3962,12 +3962,12 @@
         </p:nvSpPr>
         <p:spPr>
           <a:xfrm>
-            <a:off x="502920" y="5623560"/>
-            <a:ext cx="11183112" cy="530352"/>
+            <a:off x="502920" y="5705856"/>
+            <a:ext cx="11183112" cy="457200"/>
           </a:xfrm>
           <a:prstGeom prst="roundRect">
             <a:avLst>
-              <a:gd name="adj" fmla="val 17241"/>
+              <a:gd name="adj" fmla="val 20000"/>
             </a:avLst>
           </a:prstGeom>
           <a:solidFill>
@@ -3984,8 +3984,8 @@
         </p:nvSpPr>
         <p:spPr>
           <a:xfrm>
-            <a:off x="868680" y="5623560"/>
-            <a:ext cx="7863840" cy="530352"/>
+            <a:off x="868680" y="5705856"/>
+            <a:ext cx="7863840" cy="457200"/>
           </a:xfrm>
           <a:prstGeom prst="rect">
             <a:avLst/>
@@ -4031,12 +4031,12 @@
         </p:nvSpPr>
         <p:spPr>
           <a:xfrm>
-            <a:off x="8869680" y="5705856"/>
-            <a:ext cx="2651760" cy="365760"/>
+            <a:off x="8869680" y="5788152"/>
+            <a:ext cx="2651760" cy="292608"/>
           </a:xfrm>
           <a:prstGeom prst="roundRect">
             <a:avLst>
-              <a:gd name="adj" fmla="val 20000"/>
+              <a:gd name="adj" fmla="val 25000"/>
             </a:avLst>
           </a:prstGeom>
           <a:solidFill>

</xml_diff>